<commit_message>
Cover required configuration management and progress review in the defense deck
</commit_message>
<xml_diff>
--- a/presentations/第3组_松鼠备份_答辩.pptx
+++ b/presentations/第3组_松鼠备份_答辩.pptx
@@ -2,21 +2,21 @@
 <file path=ppt/presentation.xml><?xml version="1.0" encoding="utf-8"?>
 <p:presentation xmlns:p="http://schemas.openxmlformats.org/presentationml/2006/main">
   <p:sldMasterIdLst>
-    <p:sldMasterId xmlns:r="http://schemas.openxmlformats.org/officeDocument/2006/relationships" id="2147483648" r:id="Re5b51331471248b8"/>
+    <p:sldMasterId xmlns:r="http://schemas.openxmlformats.org/officeDocument/2006/relationships" id="2147483648" r:id="Rf1ce3175539443c0"/>
   </p:sldMasterIdLst>
   <p:notesMasterIdLst>
-    <p:notesMasterId xmlns:r="http://schemas.openxmlformats.org/officeDocument/2006/relationships" r:id="Rc038739291424762"/>
+    <p:notesMasterId xmlns:r="http://schemas.openxmlformats.org/officeDocument/2006/relationships" r:id="R40fad2e16b5a4e76"/>
   </p:notesMasterIdLst>
   <p:sldIdLst>
-    <p:sldId xmlns:r="http://schemas.openxmlformats.org/officeDocument/2006/relationships" id="256" r:id="R55958afa67774432"/>
-    <p:sldId xmlns:r="http://schemas.openxmlformats.org/officeDocument/2006/relationships" id="257" r:id="R2e9ff1941c144ec9"/>
-    <p:sldId xmlns:r="http://schemas.openxmlformats.org/officeDocument/2006/relationships" id="258" r:id="R043cfe51a4744515"/>
-    <p:sldId xmlns:r="http://schemas.openxmlformats.org/officeDocument/2006/relationships" id="259" r:id="Rd616ce36db8d4da1"/>
-    <p:sldId xmlns:r="http://schemas.openxmlformats.org/officeDocument/2006/relationships" id="260" r:id="R9137370b68164737"/>
-    <p:sldId xmlns:r="http://schemas.openxmlformats.org/officeDocument/2006/relationships" id="261" r:id="R31f1e862c83e4945"/>
-    <p:sldId xmlns:r="http://schemas.openxmlformats.org/officeDocument/2006/relationships" id="262" r:id="R637ba31920a2495b"/>
-    <p:sldId xmlns:r="http://schemas.openxmlformats.org/officeDocument/2006/relationships" id="263" r:id="Raf3993ad66e74275"/>
-    <p:sldId xmlns:r="http://schemas.openxmlformats.org/officeDocument/2006/relationships" id="264" r:id="Rce9f79b950e94f76"/>
+    <p:sldId xmlns:r="http://schemas.openxmlformats.org/officeDocument/2006/relationships" id="256" r:id="R9934fa7ec45e4ffa"/>
+    <p:sldId xmlns:r="http://schemas.openxmlformats.org/officeDocument/2006/relationships" id="257" r:id="R6bcbe55fdd134f74"/>
+    <p:sldId xmlns:r="http://schemas.openxmlformats.org/officeDocument/2006/relationships" id="258" r:id="Re0274eca43af4de8"/>
+    <p:sldId xmlns:r="http://schemas.openxmlformats.org/officeDocument/2006/relationships" id="259" r:id="R7e037c5b7f8a4918"/>
+    <p:sldId xmlns:r="http://schemas.openxmlformats.org/officeDocument/2006/relationships" id="260" r:id="Rd3d7944da0554c89"/>
+    <p:sldId xmlns:r="http://schemas.openxmlformats.org/officeDocument/2006/relationships" id="261" r:id="Rd71169f35c2e4bb8"/>
+    <p:sldId xmlns:r="http://schemas.openxmlformats.org/officeDocument/2006/relationships" id="262" r:id="R64cf4ec908e64a74"/>
+    <p:sldId xmlns:r="http://schemas.openxmlformats.org/officeDocument/2006/relationships" id="263" r:id="Ra6bd5cfb442f4c67"/>
+    <p:sldId xmlns:r="http://schemas.openxmlformats.org/officeDocument/2006/relationships" id="264" r:id="R6dae6644fdae4771"/>
   </p:sldIdLst>
   <p:sldSz cx="12192000" cy="6858000"/>
   <p:notesSz cx="6858000" cy="9144000"/>
@@ -640,7 +640,7 @@
           </a:p>
           <a:p xmlns:a="http://schemas.openxmlformats.org/drawingml/2006/main">
             <a:r>
-              <a:t>界面和命令行共用BackupService，调度器也复用这个服务。扫描、归档、压缩和密码封装分别由对应模块完成。Operation传递停止标志和进度，界面只在主线程更新。这样修改恢复逻辑时，两个入口的行为能够保持一致。</a:t>
+              <a:t>界面、命令行和调度器共用BackupService，扫描、归档、压缩和密码封装分开实现。开发环境是macOS、C++17和Apple Clang。Git保留真实版本历史，cpplint检查Google C++规范；修改后重新构建和测试。</a:t>
             </a:r>
           </a:p>
           <a:p xmlns:a="http://schemas.openxmlformats.org/drawingml/2006/main">
@@ -1000,7 +1000,7 @@
           </a:p>
           <a:p xmlns:a="http://schemas.openxmlformats.org/drawingml/2006/main">
             <a:r>
-              <a:t>分工按文件恢复、格式算法、界面任务划分。每人承担30个相对工作量点，都包括代码、测试、文档和演示，再轮流交叉复核。这是职责安排，实际贡献由三人确认，并用后续提交和测试记录补充。</a:t>
+              <a:t>三人主责分别是文件恢复、格式算法、界面任务，都配套测试、文档和演示，并轮流交叉复核。各模块实现与自动测试已经完成，本机人工验收和材料封版仍待完成；个人贡献按实际记录确认。</a:t>
             </a:r>
           </a:p>
           <a:p xmlns:a="http://schemas.openxmlformats.org/drawingml/2006/main">
@@ -1090,7 +1090,7 @@
           </a:p>
           <a:p xmlns:a="http://schemas.openxmlformats.org/drawingml/2006/main">
             <a:r>
-              <a:t>答辩前依次完成接手复现、界面验收、文档复核和排练。按第9讲要求，11月18日上午答辩，当晚提交材料；个人学习证书由每位成员自行完成。</a:t>
+              <a:t>10月29日完成恢复权限修复，以及取消、进度和回归测试。报告、模型和候选包已齐，接下来完成本机验收与封版，再按甘特图准备答辩。</a:t>
             </a:r>
           </a:p>
           <a:p xmlns:a="http://schemas.openxmlformats.org/drawingml/2006/main">
@@ -1100,7 +1100,7 @@
           </a:p>
           <a:p xmlns:a="http://schemas.openxmlformats.org/drawingml/2006/main">
             <a:r>
-              <a:t>备查说明（不朗读）：15秒。李想：以10月29日为起点安排接手复现、真实界面验收、材料复核和排练，11月18日答辩。甘特图是后续计划，尚未发生的日期不写成完成记录。在线Git仓库需要成员账号完成发布，个人证书各自完成。来源：课程9.pdf第38至40页，docs/planning/后续计划.csv及docs/10_学习证书办理说明.md。</a:t>
+              <a:t>备查说明（不朗读）：15秒。李想：10月29日的Git记录显示，0.1.1修复恢复权限与变化检测，0.2.0加入取消和进度，并完成回归及离线候选验证。下方甘特图保留小组答辩准备计划；未来日期不作完成证据，也不要求程序等到计划末日才能交付。当前所有软件验收按成员要求在李想的Mac完成，桌面操作等成员通知。来源：git log中的dbde327、b2b5bb9及49300b7；课程第9讲38至40页；docs/planning/后续计划.csv。</a:t>
             </a:r>
           </a:p>
         </p:txBody>
@@ -1237,7 +1237,7 @@
           <p:cNvPr id="3" name="Title">
             <a:extLst xmlns:a="http://schemas.openxmlformats.org/drawingml/2006/main">
               <a:ext uri="{FF2B5EF4-FFF2-40B4-BE49-F238E27FC236}">
-                <a16:creationId xmlns:a16="http://schemas.microsoft.com/office/drawing/2014/main" id="{4B2D7EE6-D86D-407E-8568-BE8C83410B7A}"/>
+                <a16:creationId xmlns:a16="http://schemas.microsoft.com/office/drawing/2014/main" id="{7926818F-C69C-4BC9-ACCA-749043A7A15E}"/>
               </a:ext>
             </a:extLst>
           </p:cNvPr>
@@ -1466,7 +1466,7 @@
           <p:cNvPr id="2" name="Subtitle">
             <a:extLst xmlns:a="http://schemas.openxmlformats.org/drawingml/2006/main">
               <a:ext uri="{FF2B5EF4-FFF2-40B4-BE49-F238E27FC236}">
-                <a16:creationId xmlns:a16="http://schemas.microsoft.com/office/drawing/2014/main" id="{302444F5-BD1F-491F-9A3F-699DA3B06902}"/>
+                <a16:creationId xmlns:a16="http://schemas.microsoft.com/office/drawing/2014/main" id="{CF886069-913B-4D64-9FCB-F9BD3B1EF210}"/>
               </a:ext>
             </a:extLst>
           </p:cNvPr>
@@ -1712,7 +1712,7 @@
           <p:cNvPr id="2" name="Section title">
             <a:extLst xmlns:a="http://schemas.openxmlformats.org/drawingml/2006/main">
               <a:ext uri="{FF2B5EF4-FFF2-40B4-BE49-F238E27FC236}">
-                <a16:creationId xmlns:a16="http://schemas.microsoft.com/office/drawing/2014/main" id="{16DF96F8-7FA9-4E78-8F31-3C9076DF1801}"/>
+                <a16:creationId xmlns:a16="http://schemas.microsoft.com/office/drawing/2014/main" id="{D8C24CEE-1B52-44D5-B1EC-A3AB883BE315}"/>
               </a:ext>
             </a:extLst>
           </p:cNvPr>
@@ -1958,7 +1958,7 @@
           <p:cNvPr id="3" name="Title">
             <a:extLst xmlns:a="http://schemas.openxmlformats.org/drawingml/2006/main">
               <a:ext uri="{FF2B5EF4-FFF2-40B4-BE49-F238E27FC236}">
-                <a16:creationId xmlns:a16="http://schemas.microsoft.com/office/drawing/2014/main" id="{A35B08ED-42E9-4D11-AC94-B59BD37FA146}"/>
+                <a16:creationId xmlns:a16="http://schemas.microsoft.com/office/drawing/2014/main" id="{65EA84AB-B896-4CD4-9F4A-0D9552F171BD}"/>
               </a:ext>
             </a:extLst>
           </p:cNvPr>
@@ -2187,7 +2187,7 @@
           <p:cNvPr id="2" name="Body">
             <a:extLst xmlns:a="http://schemas.openxmlformats.org/drawingml/2006/main">
               <a:ext uri="{FF2B5EF4-FFF2-40B4-BE49-F238E27FC236}">
-                <a16:creationId xmlns:a16="http://schemas.microsoft.com/office/drawing/2014/main" id="{14A8EAD5-18A2-437F-B19D-043AACDC77E3}"/>
+                <a16:creationId xmlns:a16="http://schemas.microsoft.com/office/drawing/2014/main" id="{373E4C8F-B6AB-4A23-BCFA-E681D84CA717}"/>
               </a:ext>
             </a:extLst>
           </p:cNvPr>
@@ -2433,7 +2433,7 @@
           <p:cNvPr id="4" name="Title">
             <a:extLst xmlns:a="http://schemas.openxmlformats.org/drawingml/2006/main">
               <a:ext uri="{FF2B5EF4-FFF2-40B4-BE49-F238E27FC236}">
-                <a16:creationId xmlns:a16="http://schemas.microsoft.com/office/drawing/2014/main" id="{E69699DB-7E03-4434-B29E-53BD67758EB1}"/>
+                <a16:creationId xmlns:a16="http://schemas.microsoft.com/office/drawing/2014/main" id="{0D992988-3CBF-4620-AABD-03A90EFF3A33}"/>
               </a:ext>
             </a:extLst>
           </p:cNvPr>
@@ -2662,7 +2662,7 @@
           <p:cNvPr id="2" name="Left column">
             <a:extLst xmlns:a="http://schemas.openxmlformats.org/drawingml/2006/main">
               <a:ext uri="{FF2B5EF4-FFF2-40B4-BE49-F238E27FC236}">
-                <a16:creationId xmlns:a16="http://schemas.microsoft.com/office/drawing/2014/main" id="{2370EDC2-33F4-44FE-9BB4-13AA983E1CCB}"/>
+                <a16:creationId xmlns:a16="http://schemas.microsoft.com/office/drawing/2014/main" id="{0E234D69-7B3C-4111-93FB-A21563C851A7}"/>
               </a:ext>
             </a:extLst>
           </p:cNvPr>
@@ -2891,7 +2891,7 @@
           <p:cNvPr id="3" name="Right column">
             <a:extLst xmlns:a="http://schemas.openxmlformats.org/drawingml/2006/main">
               <a:ext uri="{FF2B5EF4-FFF2-40B4-BE49-F238E27FC236}">
-                <a16:creationId xmlns:a16="http://schemas.microsoft.com/office/drawing/2014/main" id="{B7ADBEAB-418B-44CF-928E-906E899BEE93}"/>
+                <a16:creationId xmlns:a16="http://schemas.microsoft.com/office/drawing/2014/main" id="{748E98DA-01CA-48E8-9442-E108282C6EB2}"/>
               </a:ext>
             </a:extLst>
           </p:cNvPr>
@@ -3137,7 +3137,7 @@
           <p:cNvPr id="3" name="Title">
             <a:extLst xmlns:a="http://schemas.openxmlformats.org/drawingml/2006/main">
               <a:ext uri="{FF2B5EF4-FFF2-40B4-BE49-F238E27FC236}">
-                <a16:creationId xmlns:a16="http://schemas.microsoft.com/office/drawing/2014/main" id="{FBFA3E4E-4CB9-4D86-B16C-A977DE7D75DA}"/>
+                <a16:creationId xmlns:a16="http://schemas.microsoft.com/office/drawing/2014/main" id="{43EF259C-FFB6-4E02-AE91-6100F582B241}"/>
               </a:ext>
             </a:extLst>
           </p:cNvPr>
@@ -3366,7 +3366,7 @@
           <p:cNvPr id="2" name="Left column">
             <a:extLst xmlns:a="http://schemas.openxmlformats.org/drawingml/2006/main">
               <a:ext uri="{FF2B5EF4-FFF2-40B4-BE49-F238E27FC236}">
-                <a16:creationId xmlns:a16="http://schemas.microsoft.com/office/drawing/2014/main" id="{FFF90E49-CBA9-4B1E-AD17-167AE1BCDB08}"/>
+                <a16:creationId xmlns:a16="http://schemas.microsoft.com/office/drawing/2014/main" id="{9C5CA157-0010-41A3-AC0A-D6C28345BC70}"/>
               </a:ext>
             </a:extLst>
           </p:cNvPr>
@@ -3633,12 +3633,12 @@
   </p:cSld>
   <p:clrMap bg1="lt1" tx1="dk1" bg2="lt2" tx2="dk2" accent1="accent1" accent2="accent2" accent3="accent3" accent4="accent4" accent5="accent5" accent6="accent6" hlink="hlink" folHlink="folHlink"/>
   <p:sldLayoutIdLst>
-    <p:sldLayoutId xmlns:r="http://schemas.openxmlformats.org/officeDocument/2006/relationships" id="2147483649" r:id="Raa08240736f147f3"/>
-    <p:sldLayoutId xmlns:r="http://schemas.openxmlformats.org/officeDocument/2006/relationships" id="2147483650" r:id="Rc7c0dda1d1324e2d"/>
-    <p:sldLayoutId xmlns:r="http://schemas.openxmlformats.org/officeDocument/2006/relationships" id="2147483651" r:id="Rd6e0ac45fdd1427f"/>
-    <p:sldLayoutId xmlns:r="http://schemas.openxmlformats.org/officeDocument/2006/relationships" id="2147483652" r:id="Rabbf167f92894e41"/>
-    <p:sldLayoutId xmlns:r="http://schemas.openxmlformats.org/officeDocument/2006/relationships" id="2147483653" r:id="Ra0976bec6fa148e8"/>
-    <p:sldLayoutId xmlns:r="http://schemas.openxmlformats.org/officeDocument/2006/relationships" id="2147483654" r:id="R2c214f346bad4e04"/>
+    <p:sldLayoutId xmlns:r="http://schemas.openxmlformats.org/officeDocument/2006/relationships" id="2147483649" r:id="R07294045baf7404b"/>
+    <p:sldLayoutId xmlns:r="http://schemas.openxmlformats.org/officeDocument/2006/relationships" id="2147483650" r:id="Rc6256dc1313f446d"/>
+    <p:sldLayoutId xmlns:r="http://schemas.openxmlformats.org/officeDocument/2006/relationships" id="2147483651" r:id="R59f12e4dd6504697"/>
+    <p:sldLayoutId xmlns:r="http://schemas.openxmlformats.org/officeDocument/2006/relationships" id="2147483652" r:id="R47856ac2ce904467"/>
+    <p:sldLayoutId xmlns:r="http://schemas.openxmlformats.org/officeDocument/2006/relationships" id="2147483653" r:id="R5f5cd482cdbc4011"/>
+    <p:sldLayoutId xmlns:r="http://schemas.openxmlformats.org/officeDocument/2006/relationships" id="2147483654" r:id="Rbc62af210edd4cd9"/>
   </p:sldLayoutIdLst>
   <p:txStyles>
     <p:titleStyle>
@@ -4189,7 +4189,7 @@
           <p:cNvPr id="5" name="">
             <a:extLst xmlns:a="http://schemas.openxmlformats.org/drawingml/2006/main">
               <a:ext uri="{FF2B5EF4-FFF2-40B4-BE49-F238E27FC236}">
-                <a16:creationId xmlns:a16="http://schemas.microsoft.com/office/drawing/2014/main" id="{63F7BB86-D226-4E71-BE7B-3F59B4B3AB19}"/>
+                <a16:creationId xmlns:a16="http://schemas.microsoft.com/office/drawing/2014/main" id="{B3685F22-CB5C-47D1-A56C-7F4776C322CB}"/>
               </a:ext>
             </a:extLst>
           </p:cNvPr>
@@ -4349,7 +4349,7 @@
           <p:cNvPr id="2" name="">
             <a:extLst xmlns:a="http://schemas.openxmlformats.org/drawingml/2006/main">
               <a:ext uri="{FF2B5EF4-FFF2-40B4-BE49-F238E27FC236}">
-                <a16:creationId xmlns:a16="http://schemas.microsoft.com/office/drawing/2014/main" id="{8856F164-C9C0-4EB0-B36E-5047B7061606}"/>
+                <a16:creationId xmlns:a16="http://schemas.microsoft.com/office/drawing/2014/main" id="{F776151A-8DA7-407C-835C-8716274A4702}"/>
               </a:ext>
             </a:extLst>
           </p:cNvPr>
@@ -4509,7 +4509,7 @@
           <p:cNvPr id="3" name="">
             <a:extLst xmlns:a="http://schemas.openxmlformats.org/drawingml/2006/main">
               <a:ext uri="{FF2B5EF4-FFF2-40B4-BE49-F238E27FC236}">
-                <a16:creationId xmlns:a16="http://schemas.microsoft.com/office/drawing/2014/main" id="{80E8FA27-3863-466E-9532-5A84645AFE8B}"/>
+                <a16:creationId xmlns:a16="http://schemas.microsoft.com/office/drawing/2014/main" id="{8C588269-ECD3-42FA-B946-FFF20C8572BE}"/>
               </a:ext>
             </a:extLst>
           </p:cNvPr>
@@ -4669,7 +4669,7 @@
           <p:cNvPr id="4" name="">
             <a:extLst xmlns:a="http://schemas.openxmlformats.org/drawingml/2006/main">
               <a:ext uri="{FF2B5EF4-FFF2-40B4-BE49-F238E27FC236}">
-                <a16:creationId xmlns:a16="http://schemas.microsoft.com/office/drawing/2014/main" id="{ABCC78D9-DC80-4B5B-891F-2A007B7565B7}"/>
+                <a16:creationId xmlns:a16="http://schemas.microsoft.com/office/drawing/2014/main" id="{D7CB578A-7E18-46AF-B942-50B09E08BBA2}"/>
               </a:ext>
             </a:extLst>
           </p:cNvPr>
@@ -4881,7 +4881,7 @@
     </p:spTree>
     <p:extLst>
       <p:ext uri="{BB962C8B-B14F-4D97-AF65-F5344CB8AC3E}">
-        <p14:creationId xmlns:p14="http://schemas.microsoft.com/office/powerpoint/2010/main" val="1376726895"/>
+        <p14:creationId xmlns:p14="http://schemas.microsoft.com/office/powerpoint/2010/main" val="484604908"/>
       </p:ext>
     </p:extLst>
   </p:cSld>
@@ -4912,7 +4912,7 @@
           <p:cNvPr id="8" name="">
             <a:extLst xmlns:a="http://schemas.openxmlformats.org/drawingml/2006/main">
               <a:ext uri="{FF2B5EF4-FFF2-40B4-BE49-F238E27FC236}">
-                <a16:creationId xmlns:a16="http://schemas.microsoft.com/office/drawing/2014/main" id="{36B2D138-90FC-42C5-AC67-3257038133FD}"/>
+                <a16:creationId xmlns:a16="http://schemas.microsoft.com/office/drawing/2014/main" id="{EE479534-9592-4AD1-89FD-CBB7BB2622CE}"/>
               </a:ext>
             </a:extLst>
           </p:cNvPr>
@@ -5072,7 +5072,7 @@
           <p:cNvPr id="2" name="">
             <a:extLst xmlns:a="http://schemas.openxmlformats.org/drawingml/2006/main">
               <a:ext uri="{FF2B5EF4-FFF2-40B4-BE49-F238E27FC236}">
-                <a16:creationId xmlns:a16="http://schemas.microsoft.com/office/drawing/2014/main" id="{E3466D1B-AA20-458D-8726-0A4E35EBF89F}"/>
+                <a16:creationId xmlns:a16="http://schemas.microsoft.com/office/drawing/2014/main" id="{F47CCA19-E6E7-40A5-B697-427B62BC6D3D}"/>
               </a:ext>
             </a:extLst>
           </p:cNvPr>
@@ -5232,7 +5232,7 @@
           <p:cNvPr id="3" name="">
             <a:extLst xmlns:a="http://schemas.openxmlformats.org/drawingml/2006/main">
               <a:ext uri="{FF2B5EF4-FFF2-40B4-BE49-F238E27FC236}">
-                <a16:creationId xmlns:a16="http://schemas.microsoft.com/office/drawing/2014/main" id="{F8AB45C1-58A4-4490-9C46-350C8298B5BE}"/>
+                <a16:creationId xmlns:a16="http://schemas.microsoft.com/office/drawing/2014/main" id="{456D7C8D-2367-4114-9EC0-60EDB4C89695}"/>
               </a:ext>
             </a:extLst>
           </p:cNvPr>
@@ -5392,7 +5392,7 @@
           <p:cNvPr id="4" name="">
             <a:extLst xmlns:a="http://schemas.openxmlformats.org/drawingml/2006/main">
               <a:ext uri="{FF2B5EF4-FFF2-40B4-BE49-F238E27FC236}">
-                <a16:creationId xmlns:a16="http://schemas.microsoft.com/office/drawing/2014/main" id="{68E3E604-6348-49F4-A4B6-462269309CA6}"/>
+                <a16:creationId xmlns:a16="http://schemas.microsoft.com/office/drawing/2014/main" id="{861E4A42-03CC-48F9-B1F4-D8E675CBB063}"/>
               </a:ext>
             </a:extLst>
           </p:cNvPr>
@@ -5579,7 +5579,7 @@
           <p:cNvPr id="5" name="">
             <a:extLst xmlns:a="http://schemas.openxmlformats.org/drawingml/2006/main">
               <a:ext uri="{FF2B5EF4-FFF2-40B4-BE49-F238E27FC236}">
-                <a16:creationId xmlns:a16="http://schemas.microsoft.com/office/drawing/2014/main" id="{3F8ECC49-54FC-4DCC-B4D5-E9BD6BC92788}"/>
+                <a16:creationId xmlns:a16="http://schemas.microsoft.com/office/drawing/2014/main" id="{43E1B2E4-C563-4BAA-A2DE-EB9DFA5A8C25}"/>
               </a:ext>
             </a:extLst>
           </p:cNvPr>
@@ -5766,7 +5766,7 @@
           <p:cNvPr id="6" name="">
             <a:extLst xmlns:a="http://schemas.openxmlformats.org/drawingml/2006/main">
               <a:ext uri="{FF2B5EF4-FFF2-40B4-BE49-F238E27FC236}">
-                <a16:creationId xmlns:a16="http://schemas.microsoft.com/office/drawing/2014/main" id="{3E1D4F57-9031-4621-91C8-A29F47B2CCB6}"/>
+                <a16:creationId xmlns:a16="http://schemas.microsoft.com/office/drawing/2014/main" id="{D3BBE32C-A930-45A5-993F-7A91EE9D8C85}"/>
               </a:ext>
             </a:extLst>
           </p:cNvPr>
@@ -5953,7 +5953,7 @@
           <p:cNvPr id="7" name="">
             <a:extLst xmlns:a="http://schemas.openxmlformats.org/drawingml/2006/main">
               <a:ext uri="{FF2B5EF4-FFF2-40B4-BE49-F238E27FC236}">
-                <a16:creationId xmlns:a16="http://schemas.microsoft.com/office/drawing/2014/main" id="{3BBCC436-D368-44A8-BD98-A2CBC426AA0F}"/>
+                <a16:creationId xmlns:a16="http://schemas.microsoft.com/office/drawing/2014/main" id="{DBC55994-7A32-4F6E-85D4-E17F2F79125C}"/>
               </a:ext>
             </a:extLst>
           </p:cNvPr>
@@ -5963,7 +5963,7 @@
           <p:nvPr/>
         </p:nvPicPr>
         <p:blipFill>
-          <a:blip xmlns:r="http://schemas.openxmlformats.org/officeDocument/2006/relationships" xmlns:a="http://schemas.openxmlformats.org/drawingml/2006/main" r:embed="R2fc92a60f7154626"/>
+          <a:blip xmlns:r="http://schemas.openxmlformats.org/officeDocument/2006/relationships" xmlns:a="http://schemas.openxmlformats.org/drawingml/2006/main" r:embed="R9988b481930a4e76"/>
           <a:stretch xmlns:a="http://schemas.openxmlformats.org/drawingml/2006/main"/>
         </p:blipFill>
         <p:spPr>
@@ -5979,7 +5979,7 @@
     </p:spTree>
     <p:extLst>
       <p:ext uri="{BB962C8B-B14F-4D97-AF65-F5344CB8AC3E}">
-        <p14:creationId xmlns:p14="http://schemas.microsoft.com/office/powerpoint/2010/main" val="269331509"/>
+        <p14:creationId xmlns:p14="http://schemas.microsoft.com/office/powerpoint/2010/main" val="2027337691"/>
       </p:ext>
     </p:extLst>
   </p:cSld>
@@ -6010,7 +6010,7 @@
           <p:cNvPr id="17" name="">
             <a:extLst xmlns:a="http://schemas.openxmlformats.org/drawingml/2006/main">
               <a:ext uri="{FF2B5EF4-FFF2-40B4-BE49-F238E27FC236}">
-                <a16:creationId xmlns:a16="http://schemas.microsoft.com/office/drawing/2014/main" id="{250D96D9-A10E-4A1A-9F83-94D48E6CD124}"/>
+                <a16:creationId xmlns:a16="http://schemas.microsoft.com/office/drawing/2014/main" id="{6AF28880-CF47-4D07-95F2-EB663CC33359}"/>
               </a:ext>
             </a:extLst>
           </p:cNvPr>
@@ -6041,7 +6041,7 @@
           <p:cNvPr id="16" name="">
             <a:extLst xmlns:a="http://schemas.openxmlformats.org/drawingml/2006/main">
               <a:ext uri="{FF2B5EF4-FFF2-40B4-BE49-F238E27FC236}">
-                <a16:creationId xmlns:a16="http://schemas.microsoft.com/office/drawing/2014/main" id="{B0B7C690-D998-4179-8CF6-A343C7266648}"/>
+                <a16:creationId xmlns:a16="http://schemas.microsoft.com/office/drawing/2014/main" id="{BA409012-4836-45BA-9E3F-DB25C5DB43AD}"/>
               </a:ext>
             </a:extLst>
           </p:cNvPr>
@@ -6072,7 +6072,7 @@
           <p:cNvPr id="15" name="">
             <a:extLst xmlns:a="http://schemas.openxmlformats.org/drawingml/2006/main">
               <a:ext uri="{FF2B5EF4-FFF2-40B4-BE49-F238E27FC236}">
-                <a16:creationId xmlns:a16="http://schemas.microsoft.com/office/drawing/2014/main" id="{885F2EA2-7080-4794-A908-7E3BDD1F3FB6}"/>
+                <a16:creationId xmlns:a16="http://schemas.microsoft.com/office/drawing/2014/main" id="{A46B87C6-744D-472C-B213-7A00C24421F7}"/>
               </a:ext>
             </a:extLst>
           </p:cNvPr>
@@ -6103,7 +6103,7 @@
           <p:cNvPr id="14" name="">
             <a:extLst xmlns:a="http://schemas.openxmlformats.org/drawingml/2006/main">
               <a:ext uri="{FF2B5EF4-FFF2-40B4-BE49-F238E27FC236}">
-                <a16:creationId xmlns:a16="http://schemas.microsoft.com/office/drawing/2014/main" id="{9B17BE43-08E9-4EE7-8C3C-764C31BE6FFE}"/>
+                <a16:creationId xmlns:a16="http://schemas.microsoft.com/office/drawing/2014/main" id="{A171B5F8-9A27-48E1-8F0C-96B0E2BC1566}"/>
               </a:ext>
             </a:extLst>
           </p:cNvPr>
@@ -6134,7 +6134,7 @@
           <p:cNvPr id="9" name="">
             <a:extLst xmlns:a="http://schemas.openxmlformats.org/drawingml/2006/main">
               <a:ext uri="{FF2B5EF4-FFF2-40B4-BE49-F238E27FC236}">
-                <a16:creationId xmlns:a16="http://schemas.microsoft.com/office/drawing/2014/main" id="{E8CC9A60-9B3D-405D-A3FB-80AD393D7ECC}"/>
+                <a16:creationId xmlns:a16="http://schemas.microsoft.com/office/drawing/2014/main" id="{3C83860E-B8DD-4E05-AA98-2B449A049F0B}"/>
               </a:ext>
             </a:extLst>
           </p:cNvPr>
@@ -6165,7 +6165,7 @@
           <p:cNvPr id="8" name="">
             <a:extLst xmlns:a="http://schemas.openxmlformats.org/drawingml/2006/main">
               <a:ext uri="{FF2B5EF4-FFF2-40B4-BE49-F238E27FC236}">
-                <a16:creationId xmlns:a16="http://schemas.microsoft.com/office/drawing/2014/main" id="{4EAFB724-0A7F-49BF-BC05-2B0C6E82B284}"/>
+                <a16:creationId xmlns:a16="http://schemas.microsoft.com/office/drawing/2014/main" id="{858943BD-3F32-49AE-8F4B-E3850B5433B3}"/>
               </a:ext>
             </a:extLst>
           </p:cNvPr>
@@ -6196,7 +6196,7 @@
           <p:cNvPr id="7" name="">
             <a:extLst xmlns:a="http://schemas.openxmlformats.org/drawingml/2006/main">
               <a:ext uri="{FF2B5EF4-FFF2-40B4-BE49-F238E27FC236}">
-                <a16:creationId xmlns:a16="http://schemas.microsoft.com/office/drawing/2014/main" id="{A63F008E-7A1F-4C58-A6D0-F44C33724095}"/>
+                <a16:creationId xmlns:a16="http://schemas.microsoft.com/office/drawing/2014/main" id="{7C8F08D5-1F25-4E46-944A-4E8393633048}"/>
               </a:ext>
             </a:extLst>
           </p:cNvPr>
@@ -6224,10 +6224,10 @@
       </p:cxnSp>
       <p:sp>
         <p:nvSpPr>
-          <p:cNvPr id="20" name="">
+          <p:cNvPr id="21" name="">
             <a:extLst xmlns:a="http://schemas.openxmlformats.org/drawingml/2006/main">
               <a:ext uri="{FF2B5EF4-FFF2-40B4-BE49-F238E27FC236}">
-                <a16:creationId xmlns:a16="http://schemas.microsoft.com/office/drawing/2014/main" id="{122B01A6-5F03-47E5-B2E0-92D6D79750CA}"/>
+                <a16:creationId xmlns:a16="http://schemas.microsoft.com/office/drawing/2014/main" id="{37473808-BC95-44E6-AC1E-7C66A6224336}"/>
               </a:ext>
             </a:extLst>
           </p:cNvPr>
@@ -6387,7 +6387,7 @@
           <p:cNvPr id="2" name="">
             <a:extLst xmlns:a="http://schemas.openxmlformats.org/drawingml/2006/main">
               <a:ext uri="{FF2B5EF4-FFF2-40B4-BE49-F238E27FC236}">
-                <a16:creationId xmlns:a16="http://schemas.microsoft.com/office/drawing/2014/main" id="{4B6FD55A-EB1E-44C6-B880-307C5E096AF3}"/>
+                <a16:creationId xmlns:a16="http://schemas.microsoft.com/office/drawing/2014/main" id="{8AF853C9-328D-475E-A969-1A68A6AC581C}"/>
               </a:ext>
             </a:extLst>
           </p:cNvPr>
@@ -6547,7 +6547,7 @@
           <p:cNvPr id="3" name="">
             <a:extLst xmlns:a="http://schemas.openxmlformats.org/drawingml/2006/main">
               <a:ext uri="{FF2B5EF4-FFF2-40B4-BE49-F238E27FC236}">
-                <a16:creationId xmlns:a16="http://schemas.microsoft.com/office/drawing/2014/main" id="{CF1C33B6-4F9C-4F83-988B-19B72C33D06C}"/>
+                <a16:creationId xmlns:a16="http://schemas.microsoft.com/office/drawing/2014/main" id="{8B0E69E2-ABD0-4300-A17C-C5E23D9E3565}"/>
               </a:ext>
             </a:extLst>
           </p:cNvPr>
@@ -6711,7 +6711,7 @@
           <p:cNvPr id="4" name="">
             <a:extLst xmlns:a="http://schemas.openxmlformats.org/drawingml/2006/main">
               <a:ext uri="{FF2B5EF4-FFF2-40B4-BE49-F238E27FC236}">
-                <a16:creationId xmlns:a16="http://schemas.microsoft.com/office/drawing/2014/main" id="{C9ADAB6B-BC65-41B3-B422-CA903DEBE4C0}"/>
+                <a16:creationId xmlns:a16="http://schemas.microsoft.com/office/drawing/2014/main" id="{1DC1CC6F-093A-4F8F-8AB7-8FF82FA00895}"/>
               </a:ext>
             </a:extLst>
           </p:cNvPr>
@@ -6875,7 +6875,7 @@
           <p:cNvPr id="5" name="">
             <a:extLst xmlns:a="http://schemas.openxmlformats.org/drawingml/2006/main">
               <a:ext uri="{FF2B5EF4-FFF2-40B4-BE49-F238E27FC236}">
-                <a16:creationId xmlns:a16="http://schemas.microsoft.com/office/drawing/2014/main" id="{8B4E4E8E-8E8C-4BB9-8340-988C86D5D4F1}"/>
+                <a16:creationId xmlns:a16="http://schemas.microsoft.com/office/drawing/2014/main" id="{46C31159-AE54-44EB-8633-92FCB136E0E5}"/>
               </a:ext>
             </a:extLst>
           </p:cNvPr>
@@ -7066,7 +7066,7 @@
           <p:cNvPr id="6" name="">
             <a:extLst xmlns:a="http://schemas.openxmlformats.org/drawingml/2006/main">
               <a:ext uri="{FF2B5EF4-FFF2-40B4-BE49-F238E27FC236}">
-                <a16:creationId xmlns:a16="http://schemas.microsoft.com/office/drawing/2014/main" id="{F3359D7E-7CB8-440F-A9B1-DAF1D9E7B236}"/>
+                <a16:creationId xmlns:a16="http://schemas.microsoft.com/office/drawing/2014/main" id="{9F20E894-BA50-4541-B73D-D24E90EA43C5}"/>
               </a:ext>
             </a:extLst>
           </p:cNvPr>
@@ -7257,7 +7257,7 @@
           <p:cNvPr id="10" name="">
             <a:extLst xmlns:a="http://schemas.openxmlformats.org/drawingml/2006/main">
               <a:ext uri="{FF2B5EF4-FFF2-40B4-BE49-F238E27FC236}">
-                <a16:creationId xmlns:a16="http://schemas.microsoft.com/office/drawing/2014/main" id="{163A7195-3381-47DC-A8E6-42594CF856CF}"/>
+                <a16:creationId xmlns:a16="http://schemas.microsoft.com/office/drawing/2014/main" id="{AF57D189-D61F-4937-A422-D8DC366844F5}"/>
               </a:ext>
             </a:extLst>
           </p:cNvPr>
@@ -7448,7 +7448,7 @@
           <p:cNvPr id="11" name="">
             <a:extLst xmlns:a="http://schemas.openxmlformats.org/drawingml/2006/main">
               <a:ext uri="{FF2B5EF4-FFF2-40B4-BE49-F238E27FC236}">
-                <a16:creationId xmlns:a16="http://schemas.microsoft.com/office/drawing/2014/main" id="{9B9D291D-FEF5-4F53-8EE6-9ADA55557DBF}"/>
+                <a16:creationId xmlns:a16="http://schemas.microsoft.com/office/drawing/2014/main" id="{21E90E18-90A6-4946-AB1E-78986B655912}"/>
               </a:ext>
             </a:extLst>
           </p:cNvPr>
@@ -7639,7 +7639,7 @@
           <p:cNvPr id="12" name="">
             <a:extLst xmlns:a="http://schemas.openxmlformats.org/drawingml/2006/main">
               <a:ext uri="{FF2B5EF4-FFF2-40B4-BE49-F238E27FC236}">
-                <a16:creationId xmlns:a16="http://schemas.microsoft.com/office/drawing/2014/main" id="{586B4F07-8060-4858-8067-BF5BA7BB5BD7}"/>
+                <a16:creationId xmlns:a16="http://schemas.microsoft.com/office/drawing/2014/main" id="{D7DDD5D6-5BD1-4EE5-A6EF-A77B95062873}"/>
               </a:ext>
             </a:extLst>
           </p:cNvPr>
@@ -7830,7 +7830,7 @@
           <p:cNvPr id="13" name="">
             <a:extLst xmlns:a="http://schemas.openxmlformats.org/drawingml/2006/main">
               <a:ext uri="{FF2B5EF4-FFF2-40B4-BE49-F238E27FC236}">
-                <a16:creationId xmlns:a16="http://schemas.microsoft.com/office/drawing/2014/main" id="{A7EA032F-70B3-4F94-B688-5A81540A5548}"/>
+                <a16:creationId xmlns:a16="http://schemas.microsoft.com/office/drawing/2014/main" id="{B9B85C5B-6C6B-4CF4-8944-F0770D72D22F}"/>
               </a:ext>
             </a:extLst>
           </p:cNvPr>
@@ -8021,7 +8021,7 @@
           <p:cNvPr id="18" name="">
             <a:extLst xmlns:a="http://schemas.openxmlformats.org/drawingml/2006/main">
               <a:ext uri="{FF2B5EF4-FFF2-40B4-BE49-F238E27FC236}">
-                <a16:creationId xmlns:a16="http://schemas.microsoft.com/office/drawing/2014/main" id="{5231BE95-3712-41C9-A00C-166B9B3B82F8}"/>
+                <a16:creationId xmlns:a16="http://schemas.microsoft.com/office/drawing/2014/main" id="{DC698935-88A7-477F-891A-D2ED307CFC8C}"/>
               </a:ext>
             </a:extLst>
           </p:cNvPr>
@@ -8181,7 +8181,7 @@
           <p:cNvPr id="19" name="">
             <a:extLst xmlns:a="http://schemas.openxmlformats.org/drawingml/2006/main">
               <a:ext uri="{FF2B5EF4-FFF2-40B4-BE49-F238E27FC236}">
-                <a16:creationId xmlns:a16="http://schemas.microsoft.com/office/drawing/2014/main" id="{2F567AB1-68B5-4D1D-9E99-9B022E70034A}"/>
+                <a16:creationId xmlns:a16="http://schemas.microsoft.com/office/drawing/2014/main" id="{9E8046BD-8D8C-4E25-A7DB-A199BAEC4BC2}"/>
               </a:ext>
             </a:extLst>
           </p:cNvPr>
@@ -8192,8 +8192,8 @@
         </p:nvSpPr>
         <p:spPr>
           <a:xfrm xmlns:a="http://schemas.openxmlformats.org/drawingml/2006/main">
-            <a:off x="619125" y="6057900"/>
-            <a:ext cx="10239375" cy="304800"/>
+            <a:off x="619125" y="5895975"/>
+            <a:ext cx="10239375" cy="285750"/>
           </a:xfrm>
           <a:prstGeom xmlns:a="http://schemas.openxmlformats.org/drawingml/2006/main" prst="rect">
             <a:avLst/>
@@ -8336,10 +8336,170 @@
           </a:p>
         </p:txBody>
       </p:sp>
+      <p:sp>
+        <p:nvSpPr>
+          <p:cNvPr id="20" name="">
+            <a:extLst xmlns:a="http://schemas.openxmlformats.org/drawingml/2006/main">
+              <a:ext uri="{FF2B5EF4-FFF2-40B4-BE49-F238E27FC236}">
+                <a16:creationId xmlns:a16="http://schemas.microsoft.com/office/drawing/2014/main" id="{B384F906-E145-4FA2-AE62-50DD4789014E}"/>
+              </a:ext>
+            </a:extLst>
+          </p:cNvPr>
+          <p:cNvSpPr>
+            <a:spLocks xmlns:a="http://schemas.openxmlformats.org/drawingml/2006/main" noGrp="1"/>
+          </p:cNvSpPr>
+          <p:nvPr/>
+        </p:nvSpPr>
+        <p:spPr>
+          <a:xfrm xmlns:a="http://schemas.openxmlformats.org/drawingml/2006/main">
+            <a:off x="619125" y="6257925"/>
+            <a:ext cx="10239375" cy="295275"/>
+          </a:xfrm>
+          <a:prstGeom xmlns:a="http://schemas.openxmlformats.org/drawingml/2006/main" prst="rect">
+            <a:avLst/>
+          </a:prstGeom>
+          <a:noFill xmlns:a="http://schemas.openxmlformats.org/drawingml/2006/main"/>
+          <a:ln xmlns:a="http://schemas.openxmlformats.org/drawingml/2006/main" w="0">
+            <a:noFill/>
+          </a:ln>
+        </p:spPr>
+        <p:txBody>
+          <a:bodyPr xmlns:a="http://schemas.openxmlformats.org/drawingml/2006/main" wrap="square" lIns="0" tIns="0" rIns="0" bIns="0" anchor="t"/>
+          <a:lstStyle xmlns:a="http://schemas.openxmlformats.org/drawingml/2006/main">
+            <a:defPPr algn="l">
+              <a:defRPr sz="1650" b="0">
+                <a:solidFill>
+                  <a:srgbClr val="667274"/>
+                </a:solidFill>
+                <a:latin typeface="PingFang SC"/>
+                <a:ea typeface="PingFang SC"/>
+                <a:cs typeface="PingFang SC"/>
+              </a:defRPr>
+            </a:defPPr>
+            <a:lvl1pPr algn="l">
+              <a:defRPr sz="1650" b="0">
+                <a:solidFill>
+                  <a:srgbClr val="667274"/>
+                </a:solidFill>
+                <a:latin typeface="PingFang SC"/>
+                <a:ea typeface="PingFang SC"/>
+                <a:cs typeface="PingFang SC"/>
+              </a:defRPr>
+            </a:lvl1pPr>
+            <a:lvl2pPr algn="l">
+              <a:defRPr sz="1650" b="0">
+                <a:solidFill>
+                  <a:srgbClr val="667274"/>
+                </a:solidFill>
+                <a:latin typeface="PingFang SC"/>
+                <a:ea typeface="PingFang SC"/>
+                <a:cs typeface="PingFang SC"/>
+              </a:defRPr>
+            </a:lvl2pPr>
+            <a:lvl3pPr algn="l">
+              <a:defRPr sz="1650" b="0">
+                <a:solidFill>
+                  <a:srgbClr val="667274"/>
+                </a:solidFill>
+                <a:latin typeface="PingFang SC"/>
+                <a:ea typeface="PingFang SC"/>
+                <a:cs typeface="PingFang SC"/>
+              </a:defRPr>
+            </a:lvl3pPr>
+            <a:lvl4pPr algn="l">
+              <a:defRPr sz="1650" b="0">
+                <a:solidFill>
+                  <a:srgbClr val="667274"/>
+                </a:solidFill>
+                <a:latin typeface="PingFang SC"/>
+                <a:ea typeface="PingFang SC"/>
+                <a:cs typeface="PingFang SC"/>
+              </a:defRPr>
+            </a:lvl4pPr>
+            <a:lvl5pPr algn="l">
+              <a:defRPr sz="1650" b="0">
+                <a:solidFill>
+                  <a:srgbClr val="667274"/>
+                </a:solidFill>
+                <a:latin typeface="PingFang SC"/>
+                <a:ea typeface="PingFang SC"/>
+                <a:cs typeface="PingFang SC"/>
+              </a:defRPr>
+            </a:lvl5pPr>
+            <a:lvl6pPr algn="l">
+              <a:defRPr sz="1650" b="0">
+                <a:solidFill>
+                  <a:srgbClr val="667274"/>
+                </a:solidFill>
+                <a:latin typeface="PingFang SC"/>
+                <a:ea typeface="PingFang SC"/>
+                <a:cs typeface="PingFang SC"/>
+              </a:defRPr>
+            </a:lvl6pPr>
+            <a:lvl7pPr algn="l">
+              <a:defRPr sz="1650" b="0">
+                <a:solidFill>
+                  <a:srgbClr val="667274"/>
+                </a:solidFill>
+                <a:latin typeface="PingFang SC"/>
+                <a:ea typeface="PingFang SC"/>
+                <a:cs typeface="PingFang SC"/>
+              </a:defRPr>
+            </a:lvl7pPr>
+            <a:lvl8pPr algn="l">
+              <a:defRPr sz="1650" b="0">
+                <a:solidFill>
+                  <a:srgbClr val="667274"/>
+                </a:solidFill>
+                <a:latin typeface="PingFang SC"/>
+                <a:ea typeface="PingFang SC"/>
+                <a:cs typeface="PingFang SC"/>
+              </a:defRPr>
+            </a:lvl8pPr>
+            <a:lvl9pPr algn="l">
+              <a:defRPr sz="1650" b="0">
+                <a:solidFill>
+                  <a:srgbClr val="667274"/>
+                </a:solidFill>
+                <a:latin typeface="PingFang SC"/>
+                <a:ea typeface="PingFang SC"/>
+                <a:cs typeface="PingFang SC"/>
+              </a:defRPr>
+            </a:lvl9pPr>
+          </a:lstStyle>
+          <a:p xmlns:a="http://schemas.openxmlformats.org/drawingml/2006/main">
+            <a:pPr algn="l">
+              <a:lnSpc>
+                <a:spcPct val="118000"/>
+              </a:lnSpc>
+              <a:buNone/>
+              <a:defRPr sz="1650" b="0">
+                <a:solidFill>
+                  <a:srgbClr val="667274"/>
+                </a:solidFill>
+                <a:latin typeface="PingFang SC"/>
+                <a:ea typeface="PingFang SC"/>
+                <a:cs typeface="PingFang SC"/>
+              </a:defRPr>
+            </a:pPr>
+            <a:r>
+              <a:rPr sz="1650" b="0">
+                <a:solidFill>
+                  <a:srgbClr val="667274"/>
+                </a:solidFill>
+                <a:latin typeface="PingFang SC"/>
+                <a:ea typeface="PingFang SC"/>
+                <a:cs typeface="PingFang SC"/>
+              </a:rPr>
+              <a:t>Git：main分支与真实提交历史 · cpplint：Google C++规范</a:t>
+            </a:r>
+          </a:p>
+        </p:txBody>
+      </p:sp>
     </p:spTree>
     <p:extLst>
       <p:ext uri="{BB962C8B-B14F-4D97-AF65-F5344CB8AC3E}">
-        <p14:creationId xmlns:p14="http://schemas.microsoft.com/office/powerpoint/2010/main" val="2054675311"/>
+        <p14:creationId xmlns:p14="http://schemas.microsoft.com/office/powerpoint/2010/main" val="418436601"/>
       </p:ext>
     </p:extLst>
   </p:cSld>
@@ -8370,7 +8530,7 @@
           <p:cNvPr id="5" name="">
             <a:extLst xmlns:a="http://schemas.openxmlformats.org/drawingml/2006/main">
               <a:ext uri="{FF2B5EF4-FFF2-40B4-BE49-F238E27FC236}">
-                <a16:creationId xmlns:a16="http://schemas.microsoft.com/office/drawing/2014/main" id="{C5629010-063A-465E-A8E9-73525A059540}"/>
+                <a16:creationId xmlns:a16="http://schemas.microsoft.com/office/drawing/2014/main" id="{7270DF0B-CB53-402E-9BDB-51682E187447}"/>
               </a:ext>
             </a:extLst>
           </p:cNvPr>
@@ -8530,7 +8690,7 @@
           <p:cNvPr id="2" name="">
             <a:extLst xmlns:a="http://schemas.openxmlformats.org/drawingml/2006/main">
               <a:ext uri="{FF2B5EF4-FFF2-40B4-BE49-F238E27FC236}">
-                <a16:creationId xmlns:a16="http://schemas.microsoft.com/office/drawing/2014/main" id="{8A6231FD-FEBB-46DB-814F-0A45ADF782B8}"/>
+                <a16:creationId xmlns:a16="http://schemas.microsoft.com/office/drawing/2014/main" id="{A01D3D0E-239C-4A13-98C2-675279A51AB7}"/>
               </a:ext>
             </a:extLst>
           </p:cNvPr>
@@ -8690,7 +8850,7 @@
           <p:cNvPr id="3" name="">
             <a:extLst xmlns:a="http://schemas.openxmlformats.org/drawingml/2006/main">
               <a:ext uri="{FF2B5EF4-FFF2-40B4-BE49-F238E27FC236}">
-                <a16:creationId xmlns:a16="http://schemas.microsoft.com/office/drawing/2014/main" id="{6A82CC3A-BF14-4951-855F-D538778C019C}"/>
+                <a16:creationId xmlns:a16="http://schemas.microsoft.com/office/drawing/2014/main" id="{9815707E-3B91-4AAD-8D9D-12BE69E1CBC0}"/>
               </a:ext>
             </a:extLst>
           </p:cNvPr>
@@ -9224,7 +9384,7 @@
           <p:cNvPr id="4" name="">
             <a:extLst xmlns:a="http://schemas.openxmlformats.org/drawingml/2006/main">
               <a:ext uri="{FF2B5EF4-FFF2-40B4-BE49-F238E27FC236}">
-                <a16:creationId xmlns:a16="http://schemas.microsoft.com/office/drawing/2014/main" id="{F1B8CA3B-F4B3-44C3-9597-D600FC75E8A9}"/>
+                <a16:creationId xmlns:a16="http://schemas.microsoft.com/office/drawing/2014/main" id="{AA65903A-DBD7-4A27-8944-E8AF7DA16E66}"/>
               </a:ext>
             </a:extLst>
           </p:cNvPr>
@@ -9382,7 +9542,7 @@
     </p:spTree>
     <p:extLst>
       <p:ext uri="{BB962C8B-B14F-4D97-AF65-F5344CB8AC3E}">
-        <p14:creationId xmlns:p14="http://schemas.microsoft.com/office/powerpoint/2010/main" val="2057409312"/>
+        <p14:creationId xmlns:p14="http://schemas.microsoft.com/office/powerpoint/2010/main" val="1101486914"/>
       </p:ext>
     </p:extLst>
   </p:cSld>
@@ -9413,7 +9573,7 @@
           <p:cNvPr id="10" name="">
             <a:extLst xmlns:a="http://schemas.openxmlformats.org/drawingml/2006/main">
               <a:ext uri="{FF2B5EF4-FFF2-40B4-BE49-F238E27FC236}">
-                <a16:creationId xmlns:a16="http://schemas.microsoft.com/office/drawing/2014/main" id="{4F9909E2-2C7C-4417-8FB1-1CA84C7C188A}"/>
+                <a16:creationId xmlns:a16="http://schemas.microsoft.com/office/drawing/2014/main" id="{9011D710-F6E4-4695-9A69-57323B618A8B}"/>
               </a:ext>
             </a:extLst>
           </p:cNvPr>
@@ -9444,7 +9604,7 @@
           <p:cNvPr id="9" name="">
             <a:extLst xmlns:a="http://schemas.openxmlformats.org/drawingml/2006/main">
               <a:ext uri="{FF2B5EF4-FFF2-40B4-BE49-F238E27FC236}">
-                <a16:creationId xmlns:a16="http://schemas.microsoft.com/office/drawing/2014/main" id="{3B93E7A1-A15D-4007-82D6-4EC7EAACEF41}"/>
+                <a16:creationId xmlns:a16="http://schemas.microsoft.com/office/drawing/2014/main" id="{01C4D213-C197-4BB8-9101-F597BFCE0BFE}"/>
               </a:ext>
             </a:extLst>
           </p:cNvPr>
@@ -9475,7 +9635,7 @@
           <p:cNvPr id="8" name="">
             <a:extLst xmlns:a="http://schemas.openxmlformats.org/drawingml/2006/main">
               <a:ext uri="{FF2B5EF4-FFF2-40B4-BE49-F238E27FC236}">
-                <a16:creationId xmlns:a16="http://schemas.microsoft.com/office/drawing/2014/main" id="{3A355D44-F142-47EB-A69D-24FD74003F1E}"/>
+                <a16:creationId xmlns:a16="http://schemas.microsoft.com/office/drawing/2014/main" id="{6EFD3B17-1CB4-4296-9796-4BF01A69C2F2}"/>
               </a:ext>
             </a:extLst>
           </p:cNvPr>
@@ -9506,7 +9666,7 @@
           <p:cNvPr id="15" name="">
             <a:extLst xmlns:a="http://schemas.openxmlformats.org/drawingml/2006/main">
               <a:ext uri="{FF2B5EF4-FFF2-40B4-BE49-F238E27FC236}">
-                <a16:creationId xmlns:a16="http://schemas.microsoft.com/office/drawing/2014/main" id="{8144C2E0-FBD4-41A2-98B6-01747F51BAD6}"/>
+                <a16:creationId xmlns:a16="http://schemas.microsoft.com/office/drawing/2014/main" id="{AC6DF708-E23C-41A6-B586-2A2A5A7AABC4}"/>
               </a:ext>
             </a:extLst>
           </p:cNvPr>
@@ -9666,7 +9826,7 @@
           <p:cNvPr id="2" name="">
             <a:extLst xmlns:a="http://schemas.openxmlformats.org/drawingml/2006/main">
               <a:ext uri="{FF2B5EF4-FFF2-40B4-BE49-F238E27FC236}">
-                <a16:creationId xmlns:a16="http://schemas.microsoft.com/office/drawing/2014/main" id="{509519A9-23AE-4126-9C0D-A57A2132D934}"/>
+                <a16:creationId xmlns:a16="http://schemas.microsoft.com/office/drawing/2014/main" id="{C5BB2187-E39E-4055-9CB4-8B68B007F910}"/>
               </a:ext>
             </a:extLst>
           </p:cNvPr>
@@ -9826,7 +9986,7 @@
           <p:cNvPr id="3" name="">
             <a:extLst xmlns:a="http://schemas.openxmlformats.org/drawingml/2006/main">
               <a:ext uri="{FF2B5EF4-FFF2-40B4-BE49-F238E27FC236}">
-                <a16:creationId xmlns:a16="http://schemas.microsoft.com/office/drawing/2014/main" id="{F341DFCC-5F1D-426C-97F3-41FAA86BAAD1}"/>
+                <a16:creationId xmlns:a16="http://schemas.microsoft.com/office/drawing/2014/main" id="{99AC8A82-A879-4051-88F3-897BF2F04C00}"/>
               </a:ext>
             </a:extLst>
           </p:cNvPr>
@@ -9986,7 +10146,7 @@
           <p:cNvPr id="4" name="">
             <a:extLst xmlns:a="http://schemas.openxmlformats.org/drawingml/2006/main">
               <a:ext uri="{FF2B5EF4-FFF2-40B4-BE49-F238E27FC236}">
-                <a16:creationId xmlns:a16="http://schemas.microsoft.com/office/drawing/2014/main" id="{359F9B3D-4710-4EC7-98FD-D57F0A0EDFE0}"/>
+                <a16:creationId xmlns:a16="http://schemas.microsoft.com/office/drawing/2014/main" id="{6A95DE08-2494-4A31-83EB-6D47BE87DDEA}"/>
               </a:ext>
             </a:extLst>
           </p:cNvPr>
@@ -10150,7 +10310,7 @@
           <p:cNvPr id="5" name="">
             <a:extLst xmlns:a="http://schemas.openxmlformats.org/drawingml/2006/main">
               <a:ext uri="{FF2B5EF4-FFF2-40B4-BE49-F238E27FC236}">
-                <a16:creationId xmlns:a16="http://schemas.microsoft.com/office/drawing/2014/main" id="{5CE51CCD-2445-4DCD-8C87-8B80FDBDFBB3}"/>
+                <a16:creationId xmlns:a16="http://schemas.microsoft.com/office/drawing/2014/main" id="{1289ABD2-4CCF-4163-9C8D-0582BE7CFD8A}"/>
               </a:ext>
             </a:extLst>
           </p:cNvPr>
@@ -10314,7 +10474,7 @@
           <p:cNvPr id="6" name="">
             <a:extLst xmlns:a="http://schemas.openxmlformats.org/drawingml/2006/main">
               <a:ext uri="{FF2B5EF4-FFF2-40B4-BE49-F238E27FC236}">
-                <a16:creationId xmlns:a16="http://schemas.microsoft.com/office/drawing/2014/main" id="{F62039CF-3519-4B50-9A5D-885EC9E6BE4A}"/>
+                <a16:creationId xmlns:a16="http://schemas.microsoft.com/office/drawing/2014/main" id="{2566ED52-6B4F-4F36-A53E-B9C826F023B8}"/>
               </a:ext>
             </a:extLst>
           </p:cNvPr>
@@ -10478,7 +10638,7 @@
           <p:cNvPr id="7" name="">
             <a:extLst xmlns:a="http://schemas.openxmlformats.org/drawingml/2006/main">
               <a:ext uri="{FF2B5EF4-FFF2-40B4-BE49-F238E27FC236}">
-                <a16:creationId xmlns:a16="http://schemas.microsoft.com/office/drawing/2014/main" id="{FB369FC8-81FD-4F9F-9E82-F4A1AA7C97CB}"/>
+                <a16:creationId xmlns:a16="http://schemas.microsoft.com/office/drawing/2014/main" id="{00E64314-2AE6-4C77-A851-3130E0B2CEC3}"/>
               </a:ext>
             </a:extLst>
           </p:cNvPr>
@@ -10642,7 +10802,7 @@
           <p:cNvPr id="11" name="">
             <a:extLst xmlns:a="http://schemas.openxmlformats.org/drawingml/2006/main">
               <a:ext uri="{FF2B5EF4-FFF2-40B4-BE49-F238E27FC236}">
-                <a16:creationId xmlns:a16="http://schemas.microsoft.com/office/drawing/2014/main" id="{5DB66CEC-786F-4DB3-A956-93E2094AB2F2}"/>
+                <a16:creationId xmlns:a16="http://schemas.microsoft.com/office/drawing/2014/main" id="{EEDB4B35-8335-485A-9B10-92045C701BC5}"/>
               </a:ext>
             </a:extLst>
           </p:cNvPr>
@@ -10802,7 +10962,7 @@
           <p:cNvPr id="12" name="">
             <a:extLst xmlns:a="http://schemas.openxmlformats.org/drawingml/2006/main">
               <a:ext uri="{FF2B5EF4-FFF2-40B4-BE49-F238E27FC236}">
-                <a16:creationId xmlns:a16="http://schemas.microsoft.com/office/drawing/2014/main" id="{19F6E255-1787-4900-B3AC-94D97D47017F}"/>
+                <a16:creationId xmlns:a16="http://schemas.microsoft.com/office/drawing/2014/main" id="{1F3A44EB-EA8B-43E6-8862-940F31E41712}"/>
               </a:ext>
             </a:extLst>
           </p:cNvPr>
@@ -10831,7 +10991,7 @@
           <p:cNvPr id="13" name="">
             <a:extLst xmlns:a="http://schemas.openxmlformats.org/drawingml/2006/main">
               <a:ext uri="{FF2B5EF4-FFF2-40B4-BE49-F238E27FC236}">
-                <a16:creationId xmlns:a16="http://schemas.microsoft.com/office/drawing/2014/main" id="{0D95D079-36B3-4223-A50E-CA81A72F6142}"/>
+                <a16:creationId xmlns:a16="http://schemas.microsoft.com/office/drawing/2014/main" id="{134D0C23-996B-4953-A02A-A3B02A4C0493}"/>
               </a:ext>
             </a:extLst>
           </p:cNvPr>
@@ -11018,7 +11178,7 @@
           <p:cNvPr id="14" name="">
             <a:extLst xmlns:a="http://schemas.openxmlformats.org/drawingml/2006/main">
               <a:ext uri="{FF2B5EF4-FFF2-40B4-BE49-F238E27FC236}">
-                <a16:creationId xmlns:a16="http://schemas.microsoft.com/office/drawing/2014/main" id="{F163B725-C4D5-4014-8318-40C1B99E50E8}"/>
+                <a16:creationId xmlns:a16="http://schemas.microsoft.com/office/drawing/2014/main" id="{F46862E9-95C9-487C-9F3B-E89FBDE1E1B8}"/>
               </a:ext>
             </a:extLst>
           </p:cNvPr>
@@ -11176,7 +11336,7 @@
     </p:spTree>
     <p:extLst>
       <p:ext uri="{BB962C8B-B14F-4D97-AF65-F5344CB8AC3E}">
-        <p14:creationId xmlns:p14="http://schemas.microsoft.com/office/powerpoint/2010/main" val="247495452"/>
+        <p14:creationId xmlns:p14="http://schemas.microsoft.com/office/powerpoint/2010/main" val="349563802"/>
       </p:ext>
     </p:extLst>
   </p:cSld>
@@ -11207,7 +11367,7 @@
           <p:cNvPr id="9" name="">
             <a:extLst xmlns:a="http://schemas.openxmlformats.org/drawingml/2006/main">
               <a:ext uri="{FF2B5EF4-FFF2-40B4-BE49-F238E27FC236}">
-                <a16:creationId xmlns:a16="http://schemas.microsoft.com/office/drawing/2014/main" id="{DCFD320F-2810-4D7F-85A6-76BC663A8E7A}"/>
+                <a16:creationId xmlns:a16="http://schemas.microsoft.com/office/drawing/2014/main" id="{D129AD23-AD28-475E-AD51-CA346EDA7D00}"/>
               </a:ext>
             </a:extLst>
           </p:cNvPr>
@@ -11367,7 +11527,7 @@
           <p:cNvPr id="2" name="">
             <a:extLst xmlns:a="http://schemas.openxmlformats.org/drawingml/2006/main">
               <a:ext uri="{FF2B5EF4-FFF2-40B4-BE49-F238E27FC236}">
-                <a16:creationId xmlns:a16="http://schemas.microsoft.com/office/drawing/2014/main" id="{ECBEFE38-4452-485C-A4F9-7F73E0CB2DD1}"/>
+                <a16:creationId xmlns:a16="http://schemas.microsoft.com/office/drawing/2014/main" id="{E0CBD129-B046-4224-9BC8-63350D71EEA8}"/>
               </a:ext>
             </a:extLst>
           </p:cNvPr>
@@ -11527,7 +11687,7 @@
           <p:cNvPr id="3" name="">
             <a:extLst xmlns:a="http://schemas.openxmlformats.org/drawingml/2006/main">
               <a:ext uri="{FF2B5EF4-FFF2-40B4-BE49-F238E27FC236}">
-                <a16:creationId xmlns:a16="http://schemas.microsoft.com/office/drawing/2014/main" id="{69659FFD-2571-457B-9B0A-F3503FD326D1}"/>
+                <a16:creationId xmlns:a16="http://schemas.microsoft.com/office/drawing/2014/main" id="{068699CC-1FD9-4249-ACB0-7E1893D9F667}"/>
               </a:ext>
             </a:extLst>
           </p:cNvPr>
@@ -11687,7 +11847,7 @@
           <p:cNvPr id="4" name="">
             <a:extLst xmlns:a="http://schemas.openxmlformats.org/drawingml/2006/main">
               <a:ext uri="{FF2B5EF4-FFF2-40B4-BE49-F238E27FC236}">
-                <a16:creationId xmlns:a16="http://schemas.microsoft.com/office/drawing/2014/main" id="{CE2D5E9C-93D5-42BD-9E22-FD5517F26237}"/>
+                <a16:creationId xmlns:a16="http://schemas.microsoft.com/office/drawing/2014/main" id="{788F8F23-09E6-41AA-9379-1F6E88984CF8}"/>
               </a:ext>
             </a:extLst>
           </p:cNvPr>
@@ -11847,7 +12007,7 @@
           <p:cNvPr id="5" name="">
             <a:extLst xmlns:a="http://schemas.openxmlformats.org/drawingml/2006/main">
               <a:ext uri="{FF2B5EF4-FFF2-40B4-BE49-F238E27FC236}">
-                <a16:creationId xmlns:a16="http://schemas.microsoft.com/office/drawing/2014/main" id="{EC277397-ED8B-47A1-A0D5-361C6FA581A4}"/>
+                <a16:creationId xmlns:a16="http://schemas.microsoft.com/office/drawing/2014/main" id="{DD426079-3C9D-4283-9EAA-3591381383FA}"/>
               </a:ext>
             </a:extLst>
           </p:cNvPr>
@@ -12034,7 +12194,7 @@
           <p:cNvPr id="6" name="">
             <a:extLst xmlns:a="http://schemas.openxmlformats.org/drawingml/2006/main">
               <a:ext uri="{FF2B5EF4-FFF2-40B4-BE49-F238E27FC236}">
-                <a16:creationId xmlns:a16="http://schemas.microsoft.com/office/drawing/2014/main" id="{6841E42B-6324-4677-A1DC-EE314AB32C05}"/>
+                <a16:creationId xmlns:a16="http://schemas.microsoft.com/office/drawing/2014/main" id="{89B0B4C0-7543-4D44-BEB7-7BCD1786CC1A}"/>
               </a:ext>
             </a:extLst>
           </p:cNvPr>
@@ -12457,7 +12617,7 @@
           <p:cNvPr id="7" name="">
             <a:extLst xmlns:a="http://schemas.openxmlformats.org/drawingml/2006/main">
               <a:ext uri="{FF2B5EF4-FFF2-40B4-BE49-F238E27FC236}">
-                <a16:creationId xmlns:a16="http://schemas.microsoft.com/office/drawing/2014/main" id="{F04F919A-9862-4469-B720-43E6F10F31A0}"/>
+                <a16:creationId xmlns:a16="http://schemas.microsoft.com/office/drawing/2014/main" id="{A3362F9E-8CF4-4A61-9FD0-E62941E6CDBD}"/>
               </a:ext>
             </a:extLst>
           </p:cNvPr>
@@ -12617,7 +12777,7 @@
           <p:cNvPr id="8" name="">
             <a:extLst xmlns:a="http://schemas.openxmlformats.org/drawingml/2006/main">
               <a:ext uri="{FF2B5EF4-FFF2-40B4-BE49-F238E27FC236}">
-                <a16:creationId xmlns:a16="http://schemas.microsoft.com/office/drawing/2014/main" id="{50F96759-49D5-4230-9E68-20964015DFDE}"/>
+                <a16:creationId xmlns:a16="http://schemas.microsoft.com/office/drawing/2014/main" id="{A4B7CDDB-96E8-42DA-8356-58F2A18CCC00}"/>
               </a:ext>
             </a:extLst>
           </p:cNvPr>
@@ -12775,7 +12935,7 @@
     </p:spTree>
     <p:extLst>
       <p:ext uri="{BB962C8B-B14F-4D97-AF65-F5344CB8AC3E}">
-        <p14:creationId xmlns:p14="http://schemas.microsoft.com/office/powerpoint/2010/main" val="626285730"/>
+        <p14:creationId xmlns:p14="http://schemas.microsoft.com/office/powerpoint/2010/main" val="633093857"/>
       </p:ext>
     </p:extLst>
   </p:cSld>
@@ -12806,7 +12966,7 @@
           <p:cNvPr id="6" name="">
             <a:extLst xmlns:a="http://schemas.openxmlformats.org/drawingml/2006/main">
               <a:ext uri="{FF2B5EF4-FFF2-40B4-BE49-F238E27FC236}">
-                <a16:creationId xmlns:a16="http://schemas.microsoft.com/office/drawing/2014/main" id="{38F002D7-9910-4C6D-B3CE-79E68A637107}"/>
+                <a16:creationId xmlns:a16="http://schemas.microsoft.com/office/drawing/2014/main" id="{6D7C5DC6-2F17-4D64-A2CD-DFCB1651DDDD}"/>
               </a:ext>
             </a:extLst>
           </p:cNvPr>
@@ -12966,7 +13126,7 @@
           <p:cNvPr id="2" name="">
             <a:extLst xmlns:a="http://schemas.openxmlformats.org/drawingml/2006/main">
               <a:ext uri="{FF2B5EF4-FFF2-40B4-BE49-F238E27FC236}">
-                <a16:creationId xmlns:a16="http://schemas.microsoft.com/office/drawing/2014/main" id="{8D0302CB-0226-4135-B0E8-442BF3B3174A}"/>
+                <a16:creationId xmlns:a16="http://schemas.microsoft.com/office/drawing/2014/main" id="{9D0B82E5-8DB4-4DAC-A495-4303EFB80A2D}"/>
               </a:ext>
             </a:extLst>
           </p:cNvPr>
@@ -13126,7 +13286,7 @@
           <p:cNvPr id="3" name="">
             <a:extLst xmlns:a="http://schemas.openxmlformats.org/drawingml/2006/main">
               <a:ext uri="{FF2B5EF4-FFF2-40B4-BE49-F238E27FC236}">
-                <a16:creationId xmlns:a16="http://schemas.microsoft.com/office/drawing/2014/main" id="{8C41A6BB-D8FB-403D-8719-5C130D7425F9}"/>
+                <a16:creationId xmlns:a16="http://schemas.microsoft.com/office/drawing/2014/main" id="{C88D1F35-8EE3-49E6-BB7D-7261971F139A}"/>
               </a:ext>
             </a:extLst>
           </p:cNvPr>
@@ -13618,7 +13778,7 @@
           <p:cNvPr id="4" name="">
             <a:extLst xmlns:a="http://schemas.openxmlformats.org/drawingml/2006/main">
               <a:ext uri="{FF2B5EF4-FFF2-40B4-BE49-F238E27FC236}">
-                <a16:creationId xmlns:a16="http://schemas.microsoft.com/office/drawing/2014/main" id="{92069799-5520-4BB5-944F-B87FBB6647F5}"/>
+                <a16:creationId xmlns:a16="http://schemas.microsoft.com/office/drawing/2014/main" id="{FB8F7581-B835-4AB0-9500-278EFD0D81ED}"/>
               </a:ext>
             </a:extLst>
           </p:cNvPr>
@@ -13768,7 +13928,7 @@
                 <a:ea typeface="PingFang SC"/>
                 <a:cs typeface="PingFang SC"/>
               </a:rPr>
-              <a:t>每人30点：实现14 + 测试5 + 文档建模5 + 复核演示6</a:t>
+              <a:t>实现与自动测试已完成；本机验收和材料封版待完成</a:t>
             </a:r>
           </a:p>
         </p:txBody>
@@ -13778,7 +13938,7 @@
           <p:cNvPr id="5" name="">
             <a:extLst xmlns:a="http://schemas.openxmlformats.org/drawingml/2006/main">
               <a:ext uri="{FF2B5EF4-FFF2-40B4-BE49-F238E27FC236}">
-                <a16:creationId xmlns:a16="http://schemas.microsoft.com/office/drawing/2014/main" id="{E8E96003-3E87-4ABA-AF69-8445BEE8691D}"/>
+                <a16:creationId xmlns:a16="http://schemas.microsoft.com/office/drawing/2014/main" id="{2CDCACE6-83B4-46DF-8356-B182301293B8}"/>
               </a:ext>
             </a:extLst>
           </p:cNvPr>
@@ -13936,7 +14096,7 @@
     </p:spTree>
     <p:extLst>
       <p:ext uri="{BB962C8B-B14F-4D97-AF65-F5344CB8AC3E}">
-        <p14:creationId xmlns:p14="http://schemas.microsoft.com/office/powerpoint/2010/main" val="880229183"/>
+        <p14:creationId xmlns:p14="http://schemas.microsoft.com/office/powerpoint/2010/main" val="1360271040"/>
       </p:ext>
     </p:extLst>
   </p:cSld>
@@ -13964,10 +14124,10 @@
       </p:grpSpPr>
       <p:sp>
         <p:nvSpPr>
-          <p:cNvPr id="26" name="">
+          <p:cNvPr id="29" name="">
             <a:extLst xmlns:a="http://schemas.openxmlformats.org/drawingml/2006/main">
               <a:ext uri="{FF2B5EF4-FFF2-40B4-BE49-F238E27FC236}">
-                <a16:creationId xmlns:a16="http://schemas.microsoft.com/office/drawing/2014/main" id="{50C8E0CA-3009-4EC6-A1DB-D6B09A0418F1}"/>
+                <a16:creationId xmlns:a16="http://schemas.microsoft.com/office/drawing/2014/main" id="{90D3F2D5-6A97-455A-B9C2-DFCC16753244}"/>
               </a:ext>
             </a:extLst>
           </p:cNvPr>
@@ -14117,7 +14277,7 @@
                 <a:ea typeface="PingFang SC"/>
                 <a:cs typeface="PingFang SC"/>
               </a:rPr>
-              <a:t>答辩前推进计划</a:t>
+              <a:t>项目进展与后续安排</a:t>
             </a:r>
           </a:p>
         </p:txBody>
@@ -14127,7 +14287,7 @@
           <p:cNvPr id="2" name="">
             <a:extLst xmlns:a="http://schemas.openxmlformats.org/drawingml/2006/main">
               <a:ext uri="{FF2B5EF4-FFF2-40B4-BE49-F238E27FC236}">
-                <a16:creationId xmlns:a16="http://schemas.microsoft.com/office/drawing/2014/main" id="{B44B5B2D-C6E2-42DD-B140-CEE380F18C09}"/>
+                <a16:creationId xmlns:a16="http://schemas.microsoft.com/office/drawing/2014/main" id="{ED1BA707-8E1E-4705-82E4-28ADD7780DBD}"/>
               </a:ext>
             </a:extLst>
           </p:cNvPr>
@@ -14287,7 +14447,7 @@
           <p:cNvPr id="3" name="">
             <a:extLst xmlns:a="http://schemas.openxmlformats.org/drawingml/2006/main">
               <a:ext uri="{FF2B5EF4-FFF2-40B4-BE49-F238E27FC236}">
-                <a16:creationId xmlns:a16="http://schemas.microsoft.com/office/drawing/2014/main" id="{83BEB96F-6BE9-4D91-9E44-2DF643E905C3}"/>
+                <a16:creationId xmlns:a16="http://schemas.microsoft.com/office/drawing/2014/main" id="{1484F8C1-2994-4A07-B8F6-16090B6D060D}"/>
               </a:ext>
             </a:extLst>
           </p:cNvPr>
@@ -14298,8 +14458,328 @@
         </p:nvSpPr>
         <p:spPr>
           <a:xfrm xmlns:a="http://schemas.openxmlformats.org/drawingml/2006/main">
-            <a:off x="3228975" y="1533525"/>
-            <a:ext cx="838200" cy="381000"/>
+            <a:off x="619125" y="1295400"/>
+            <a:ext cx="10858500" cy="419100"/>
+          </a:xfrm>
+          <a:prstGeom xmlns:a="http://schemas.openxmlformats.org/drawingml/2006/main" prst="rect">
+            <a:avLst/>
+          </a:prstGeom>
+          <a:noFill xmlns:a="http://schemas.openxmlformats.org/drawingml/2006/main"/>
+          <a:ln xmlns:a="http://schemas.openxmlformats.org/drawingml/2006/main" w="0">
+            <a:noFill/>
+          </a:ln>
+        </p:spPr>
+        <p:txBody>
+          <a:bodyPr xmlns:a="http://schemas.openxmlformats.org/drawingml/2006/main" wrap="square" lIns="0" tIns="0" rIns="0" bIns="0" anchor="t"/>
+          <a:lstStyle xmlns:a="http://schemas.openxmlformats.org/drawingml/2006/main">
+            <a:defPPr algn="l">
+              <a:defRPr sz="2175" b="1">
+                <a:solidFill>
+                  <a:srgbClr val="AC4B30"/>
+                </a:solidFill>
+                <a:latin typeface="PingFang SC"/>
+                <a:ea typeface="PingFang SC"/>
+                <a:cs typeface="PingFang SC"/>
+              </a:defRPr>
+            </a:defPPr>
+            <a:lvl1pPr algn="l">
+              <a:defRPr sz="2175" b="1">
+                <a:solidFill>
+                  <a:srgbClr val="AC4B30"/>
+                </a:solidFill>
+                <a:latin typeface="PingFang SC"/>
+                <a:ea typeface="PingFang SC"/>
+                <a:cs typeface="PingFang SC"/>
+              </a:defRPr>
+            </a:lvl1pPr>
+            <a:lvl2pPr algn="l">
+              <a:defRPr sz="2175" b="1">
+                <a:solidFill>
+                  <a:srgbClr val="AC4B30"/>
+                </a:solidFill>
+                <a:latin typeface="PingFang SC"/>
+                <a:ea typeface="PingFang SC"/>
+                <a:cs typeface="PingFang SC"/>
+              </a:defRPr>
+            </a:lvl2pPr>
+            <a:lvl3pPr algn="l">
+              <a:defRPr sz="2175" b="1">
+                <a:solidFill>
+                  <a:srgbClr val="AC4B30"/>
+                </a:solidFill>
+                <a:latin typeface="PingFang SC"/>
+                <a:ea typeface="PingFang SC"/>
+                <a:cs typeface="PingFang SC"/>
+              </a:defRPr>
+            </a:lvl3pPr>
+            <a:lvl4pPr algn="l">
+              <a:defRPr sz="2175" b="1">
+                <a:solidFill>
+                  <a:srgbClr val="AC4B30"/>
+                </a:solidFill>
+                <a:latin typeface="PingFang SC"/>
+                <a:ea typeface="PingFang SC"/>
+                <a:cs typeface="PingFang SC"/>
+              </a:defRPr>
+            </a:lvl4pPr>
+            <a:lvl5pPr algn="l">
+              <a:defRPr sz="2175" b="1">
+                <a:solidFill>
+                  <a:srgbClr val="AC4B30"/>
+                </a:solidFill>
+                <a:latin typeface="PingFang SC"/>
+                <a:ea typeface="PingFang SC"/>
+                <a:cs typeface="PingFang SC"/>
+              </a:defRPr>
+            </a:lvl5pPr>
+            <a:lvl6pPr algn="l">
+              <a:defRPr sz="2175" b="1">
+                <a:solidFill>
+                  <a:srgbClr val="AC4B30"/>
+                </a:solidFill>
+                <a:latin typeface="PingFang SC"/>
+                <a:ea typeface="PingFang SC"/>
+                <a:cs typeface="PingFang SC"/>
+              </a:defRPr>
+            </a:lvl6pPr>
+            <a:lvl7pPr algn="l">
+              <a:defRPr sz="2175" b="1">
+                <a:solidFill>
+                  <a:srgbClr val="AC4B30"/>
+                </a:solidFill>
+                <a:latin typeface="PingFang SC"/>
+                <a:ea typeface="PingFang SC"/>
+                <a:cs typeface="PingFang SC"/>
+              </a:defRPr>
+            </a:lvl7pPr>
+            <a:lvl8pPr algn="l">
+              <a:defRPr sz="2175" b="1">
+                <a:solidFill>
+                  <a:srgbClr val="AC4B30"/>
+                </a:solidFill>
+                <a:latin typeface="PingFang SC"/>
+                <a:ea typeface="PingFang SC"/>
+                <a:cs typeface="PingFang SC"/>
+              </a:defRPr>
+            </a:lvl8pPr>
+            <a:lvl9pPr algn="l">
+              <a:defRPr sz="2175" b="1">
+                <a:solidFill>
+                  <a:srgbClr val="AC4B30"/>
+                </a:solidFill>
+                <a:latin typeface="PingFang SC"/>
+                <a:ea typeface="PingFang SC"/>
+                <a:cs typeface="PingFang SC"/>
+              </a:defRPr>
+            </a:lvl9pPr>
+          </a:lstStyle>
+          <a:p xmlns:a="http://schemas.openxmlformats.org/drawingml/2006/main">
+            <a:pPr algn="l">
+              <a:lnSpc>
+                <a:spcPct val="118000"/>
+              </a:lnSpc>
+              <a:buNone/>
+              <a:defRPr sz="2175" b="1">
+                <a:solidFill>
+                  <a:srgbClr val="AC4B30"/>
+                </a:solidFill>
+                <a:latin typeface="PingFang SC"/>
+                <a:ea typeface="PingFang SC"/>
+                <a:cs typeface="PingFang SC"/>
+              </a:defRPr>
+            </a:pPr>
+            <a:r>
+              <a:rPr sz="2175" b="1">
+                <a:solidFill>
+                  <a:srgbClr val="AC4B30"/>
+                </a:solidFill>
+                <a:latin typeface="PingFang SC"/>
+                <a:ea typeface="PingFang SC"/>
+                <a:cs typeface="PingFang SC"/>
+              </a:rPr>
+              <a:t>10/29：0.1.0基线 → 0.1.1恢复修复 → 0.2.0取消与进度</a:t>
+            </a:r>
+          </a:p>
+        </p:txBody>
+      </p:sp>
+      <p:sp>
+        <p:nvSpPr>
+          <p:cNvPr id="4" name="">
+            <a:extLst xmlns:a="http://schemas.openxmlformats.org/drawingml/2006/main">
+              <a:ext uri="{FF2B5EF4-FFF2-40B4-BE49-F238E27FC236}">
+                <a16:creationId xmlns:a16="http://schemas.microsoft.com/office/drawing/2014/main" id="{353621B1-5B3D-4CD5-A9A8-AEC24C2E24B6}"/>
+              </a:ext>
+            </a:extLst>
+          </p:cNvPr>
+          <p:cNvSpPr>
+            <a:spLocks xmlns:a="http://schemas.openxmlformats.org/drawingml/2006/main" noGrp="1"/>
+          </p:cNvSpPr>
+          <p:nvPr/>
+        </p:nvSpPr>
+        <p:spPr>
+          <a:xfrm xmlns:a="http://schemas.openxmlformats.org/drawingml/2006/main">
+            <a:off x="619125" y="1781175"/>
+            <a:ext cx="10858500" cy="381000"/>
+          </a:xfrm>
+          <a:prstGeom xmlns:a="http://schemas.openxmlformats.org/drawingml/2006/main" prst="rect">
+            <a:avLst/>
+          </a:prstGeom>
+          <a:noFill xmlns:a="http://schemas.openxmlformats.org/drawingml/2006/main"/>
+          <a:ln xmlns:a="http://schemas.openxmlformats.org/drawingml/2006/main" w="0">
+            <a:noFill/>
+          </a:ln>
+        </p:spPr>
+        <p:txBody>
+          <a:bodyPr xmlns:a="http://schemas.openxmlformats.org/drawingml/2006/main" wrap="square" lIns="0" tIns="0" rIns="0" bIns="0" anchor="t"/>
+          <a:lstStyle xmlns:a="http://schemas.openxmlformats.org/drawingml/2006/main">
+            <a:defPPr algn="l">
+              <a:defRPr sz="2025" b="0">
+                <a:solidFill>
+                  <a:srgbClr val="222D32"/>
+                </a:solidFill>
+                <a:latin typeface="PingFang SC"/>
+                <a:ea typeface="PingFang SC"/>
+                <a:cs typeface="PingFang SC"/>
+              </a:defRPr>
+            </a:defPPr>
+            <a:lvl1pPr algn="l">
+              <a:defRPr sz="2025" b="0">
+                <a:solidFill>
+                  <a:srgbClr val="222D32"/>
+                </a:solidFill>
+                <a:latin typeface="PingFang SC"/>
+                <a:ea typeface="PingFang SC"/>
+                <a:cs typeface="PingFang SC"/>
+              </a:defRPr>
+            </a:lvl1pPr>
+            <a:lvl2pPr algn="l">
+              <a:defRPr sz="2025" b="0">
+                <a:solidFill>
+                  <a:srgbClr val="222D32"/>
+                </a:solidFill>
+                <a:latin typeface="PingFang SC"/>
+                <a:ea typeface="PingFang SC"/>
+                <a:cs typeface="PingFang SC"/>
+              </a:defRPr>
+            </a:lvl2pPr>
+            <a:lvl3pPr algn="l">
+              <a:defRPr sz="2025" b="0">
+                <a:solidFill>
+                  <a:srgbClr val="222D32"/>
+                </a:solidFill>
+                <a:latin typeface="PingFang SC"/>
+                <a:ea typeface="PingFang SC"/>
+                <a:cs typeface="PingFang SC"/>
+              </a:defRPr>
+            </a:lvl3pPr>
+            <a:lvl4pPr algn="l">
+              <a:defRPr sz="2025" b="0">
+                <a:solidFill>
+                  <a:srgbClr val="222D32"/>
+                </a:solidFill>
+                <a:latin typeface="PingFang SC"/>
+                <a:ea typeface="PingFang SC"/>
+                <a:cs typeface="PingFang SC"/>
+              </a:defRPr>
+            </a:lvl4pPr>
+            <a:lvl5pPr algn="l">
+              <a:defRPr sz="2025" b="0">
+                <a:solidFill>
+                  <a:srgbClr val="222D32"/>
+                </a:solidFill>
+                <a:latin typeface="PingFang SC"/>
+                <a:ea typeface="PingFang SC"/>
+                <a:cs typeface="PingFang SC"/>
+              </a:defRPr>
+            </a:lvl5pPr>
+            <a:lvl6pPr algn="l">
+              <a:defRPr sz="2025" b="0">
+                <a:solidFill>
+                  <a:srgbClr val="222D32"/>
+                </a:solidFill>
+                <a:latin typeface="PingFang SC"/>
+                <a:ea typeface="PingFang SC"/>
+                <a:cs typeface="PingFang SC"/>
+              </a:defRPr>
+            </a:lvl6pPr>
+            <a:lvl7pPr algn="l">
+              <a:defRPr sz="2025" b="0">
+                <a:solidFill>
+                  <a:srgbClr val="222D32"/>
+                </a:solidFill>
+                <a:latin typeface="PingFang SC"/>
+                <a:ea typeface="PingFang SC"/>
+                <a:cs typeface="PingFang SC"/>
+              </a:defRPr>
+            </a:lvl7pPr>
+            <a:lvl8pPr algn="l">
+              <a:defRPr sz="2025" b="0">
+                <a:solidFill>
+                  <a:srgbClr val="222D32"/>
+                </a:solidFill>
+                <a:latin typeface="PingFang SC"/>
+                <a:ea typeface="PingFang SC"/>
+                <a:cs typeface="PingFang SC"/>
+              </a:defRPr>
+            </a:lvl8pPr>
+            <a:lvl9pPr algn="l">
+              <a:defRPr sz="2025" b="0">
+                <a:solidFill>
+                  <a:srgbClr val="222D32"/>
+                </a:solidFill>
+                <a:latin typeface="PingFang SC"/>
+                <a:ea typeface="PingFang SC"/>
+                <a:cs typeface="PingFang SC"/>
+              </a:defRPr>
+            </a:lvl9pPr>
+          </a:lstStyle>
+          <a:p xmlns:a="http://schemas.openxmlformats.org/drawingml/2006/main">
+            <a:pPr algn="l">
+              <a:lnSpc>
+                <a:spcPct val="118000"/>
+              </a:lnSpc>
+              <a:buNone/>
+              <a:defRPr sz="2025" b="0">
+                <a:solidFill>
+                  <a:srgbClr val="222D32"/>
+                </a:solidFill>
+                <a:latin typeface="PingFang SC"/>
+                <a:ea typeface="PingFang SC"/>
+                <a:cs typeface="PingFang SC"/>
+              </a:defRPr>
+            </a:pPr>
+            <a:r>
+              <a:rPr sz="2025" b="0">
+                <a:solidFill>
+                  <a:srgbClr val="222D32"/>
+                </a:solidFill>
+                <a:latin typeface="PingFang SC"/>
+                <a:ea typeface="PingFang SC"/>
+                <a:cs typeface="PingFang SC"/>
+              </a:rPr>
+              <a:t>97项回归通过；报告、UML、视频和离线候选包已形成</a:t>
+            </a:r>
+          </a:p>
+        </p:txBody>
+      </p:sp>
+      <p:sp>
+        <p:nvSpPr>
+          <p:cNvPr id="5" name="">
+            <a:extLst xmlns:a="http://schemas.openxmlformats.org/drawingml/2006/main">
+              <a:ext uri="{FF2B5EF4-FFF2-40B4-BE49-F238E27FC236}">
+                <a16:creationId xmlns:a16="http://schemas.microsoft.com/office/drawing/2014/main" id="{5990F1C2-FD0E-4066-B389-5386739851AC}"/>
+              </a:ext>
+            </a:extLst>
+          </p:cNvPr>
+          <p:cNvSpPr>
+            <a:spLocks xmlns:a="http://schemas.openxmlformats.org/drawingml/2006/main" noGrp="1"/>
+          </p:cNvSpPr>
+          <p:nvPr/>
+        </p:nvSpPr>
+        <p:spPr>
+          <a:xfrm xmlns:a="http://schemas.openxmlformats.org/drawingml/2006/main">
+            <a:off x="638175" y="2400300"/>
+            <a:ext cx="2714625" cy="342900"/>
           </a:xfrm>
           <a:prstGeom xmlns:a="http://schemas.openxmlformats.org/drawingml/2006/main" prst="rect">
             <a:avLst/>
@@ -14437,17 +14917,17 @@
                 <a:ea typeface="PingFang SC"/>
                 <a:cs typeface="PingFang SC"/>
               </a:rPr>
-              <a:t>10/29</a:t>
+              <a:t>后续答辩准备计划</a:t>
             </a:r>
           </a:p>
         </p:txBody>
       </p:sp>
       <p:sp>
         <p:nvSpPr>
-          <p:cNvPr id="4" name="">
+          <p:cNvPr id="6" name="">
             <a:extLst xmlns:a="http://schemas.openxmlformats.org/drawingml/2006/main">
               <a:ext uri="{FF2B5EF4-FFF2-40B4-BE49-F238E27FC236}">
-                <a16:creationId xmlns:a16="http://schemas.microsoft.com/office/drawing/2014/main" id="{78110DA9-A9BD-451D-BA2F-01DA517B48A2}"/>
+                <a16:creationId xmlns:a16="http://schemas.microsoft.com/office/drawing/2014/main" id="{2E0756C3-F498-4DD5-95BB-8EB7604A8192}"/>
               </a:ext>
             </a:extLst>
           </p:cNvPr>
@@ -14458,37 +14938,8 @@
         </p:nvSpPr>
         <p:spPr>
           <a:xfrm xmlns:a="http://schemas.openxmlformats.org/drawingml/2006/main">
-            <a:off x="3495675" y="2009775"/>
-            <a:ext cx="0" cy="3419475"/>
-          </a:xfrm>
-          <a:prstGeom xmlns:a="http://schemas.openxmlformats.org/drawingml/2006/main" prst="line">
-            <a:avLst/>
-          </a:prstGeom>
-          <a:ln xmlns:a="http://schemas.openxmlformats.org/drawingml/2006/main" w="9525">
-            <a:solidFill>
-              <a:srgbClr val="DDE2DF"/>
-            </a:solidFill>
-          </a:ln>
-        </p:spPr>
-      </p:sp>
-      <p:sp>
-        <p:nvSpPr>
-          <p:cNvPr id="5" name="">
-            <a:extLst xmlns:a="http://schemas.openxmlformats.org/drawingml/2006/main">
-              <a:ext uri="{FF2B5EF4-FFF2-40B4-BE49-F238E27FC236}">
-                <a16:creationId xmlns:a16="http://schemas.microsoft.com/office/drawing/2014/main" id="{5E8FB01C-6C20-49ED-8B96-A8065856380D}"/>
-              </a:ext>
-            </a:extLst>
-          </p:cNvPr>
-          <p:cNvSpPr>
-            <a:spLocks xmlns:a="http://schemas.openxmlformats.org/drawingml/2006/main" noGrp="1"/>
-          </p:cNvSpPr>
-          <p:nvPr/>
-        </p:nvSpPr>
-        <p:spPr>
-          <a:xfrm xmlns:a="http://schemas.openxmlformats.org/drawingml/2006/main">
-            <a:off x="4343400" y="1533525"/>
-            <a:ext cx="838200" cy="381000"/>
+            <a:off x="3228975" y="2400300"/>
+            <a:ext cx="838200" cy="342900"/>
           </a:xfrm>
           <a:prstGeom xmlns:a="http://schemas.openxmlformats.org/drawingml/2006/main" prst="rect">
             <a:avLst/>
@@ -14626,17 +15077,17 @@
                 <a:ea typeface="PingFang SC"/>
                 <a:cs typeface="PingFang SC"/>
               </a:rPr>
-              <a:t>11/1</a:t>
+              <a:t>10/29</a:t>
             </a:r>
           </a:p>
         </p:txBody>
       </p:sp>
       <p:sp>
         <p:nvSpPr>
-          <p:cNvPr id="6" name="">
+          <p:cNvPr id="7" name="">
             <a:extLst xmlns:a="http://schemas.openxmlformats.org/drawingml/2006/main">
               <a:ext uri="{FF2B5EF4-FFF2-40B4-BE49-F238E27FC236}">
-                <a16:creationId xmlns:a16="http://schemas.microsoft.com/office/drawing/2014/main" id="{504BD3B2-39A5-4256-B8AD-153F97965041}"/>
+                <a16:creationId xmlns:a16="http://schemas.microsoft.com/office/drawing/2014/main" id="{65AAE88F-902E-4AFD-9E6F-743CF668D6C2}"/>
               </a:ext>
             </a:extLst>
           </p:cNvPr>
@@ -14647,8 +15098,8 @@
         </p:nvSpPr>
         <p:spPr>
           <a:xfrm xmlns:a="http://schemas.openxmlformats.org/drawingml/2006/main">
-            <a:off x="4610100" y="2009775"/>
-            <a:ext cx="0" cy="3419475"/>
+            <a:off x="3495675" y="2857500"/>
+            <a:ext cx="0" cy="2733675"/>
           </a:xfrm>
           <a:prstGeom xmlns:a="http://schemas.openxmlformats.org/drawingml/2006/main" prst="line">
             <a:avLst/>
@@ -14662,10 +15113,10 @@
       </p:sp>
       <p:sp>
         <p:nvSpPr>
-          <p:cNvPr id="7" name="">
+          <p:cNvPr id="8" name="">
             <a:extLst xmlns:a="http://schemas.openxmlformats.org/drawingml/2006/main">
               <a:ext uri="{FF2B5EF4-FFF2-40B4-BE49-F238E27FC236}">
-                <a16:creationId xmlns:a16="http://schemas.microsoft.com/office/drawing/2014/main" id="{CAFBFAC6-6BA0-45E2-8A6E-79D8B753E2BA}"/>
+                <a16:creationId xmlns:a16="http://schemas.microsoft.com/office/drawing/2014/main" id="{B7099A33-A242-4794-BD9A-57FC03E8BF0E}"/>
               </a:ext>
             </a:extLst>
           </p:cNvPr>
@@ -14676,8 +15127,8 @@
         </p:nvSpPr>
         <p:spPr>
           <a:xfrm xmlns:a="http://schemas.openxmlformats.org/drawingml/2006/main">
-            <a:off x="6200775" y="1533525"/>
-            <a:ext cx="838200" cy="381000"/>
+            <a:off x="4343400" y="2400300"/>
+            <a:ext cx="838200" cy="342900"/>
           </a:xfrm>
           <a:prstGeom xmlns:a="http://schemas.openxmlformats.org/drawingml/2006/main" prst="rect">
             <a:avLst/>
@@ -14815,17 +15266,17 @@
                 <a:ea typeface="PingFang SC"/>
                 <a:cs typeface="PingFang SC"/>
               </a:rPr>
-              <a:t>11/6</a:t>
+              <a:t>11/1</a:t>
             </a:r>
           </a:p>
         </p:txBody>
       </p:sp>
       <p:sp>
         <p:nvSpPr>
-          <p:cNvPr id="8" name="">
+          <p:cNvPr id="9" name="">
             <a:extLst xmlns:a="http://schemas.openxmlformats.org/drawingml/2006/main">
               <a:ext uri="{FF2B5EF4-FFF2-40B4-BE49-F238E27FC236}">
-                <a16:creationId xmlns:a16="http://schemas.microsoft.com/office/drawing/2014/main" id="{70586206-EB62-40D2-84DC-71DB56C8DA95}"/>
+                <a16:creationId xmlns:a16="http://schemas.microsoft.com/office/drawing/2014/main" id="{FF83172C-32A8-493B-A0E2-0DCB9D010A63}"/>
               </a:ext>
             </a:extLst>
           </p:cNvPr>
@@ -14836,8 +15287,8 @@
         </p:nvSpPr>
         <p:spPr>
           <a:xfrm xmlns:a="http://schemas.openxmlformats.org/drawingml/2006/main">
-            <a:off x="6467475" y="2009775"/>
-            <a:ext cx="0" cy="3419475"/>
+            <a:off x="4610100" y="2857500"/>
+            <a:ext cx="0" cy="2733675"/>
           </a:xfrm>
           <a:prstGeom xmlns:a="http://schemas.openxmlformats.org/drawingml/2006/main" prst="line">
             <a:avLst/>
@@ -14851,10 +15302,10 @@
       </p:sp>
       <p:sp>
         <p:nvSpPr>
-          <p:cNvPr id="9" name="">
+          <p:cNvPr id="10" name="">
             <a:extLst xmlns:a="http://schemas.openxmlformats.org/drawingml/2006/main">
               <a:ext uri="{FF2B5EF4-FFF2-40B4-BE49-F238E27FC236}">
-                <a16:creationId xmlns:a16="http://schemas.microsoft.com/office/drawing/2014/main" id="{199DDC1B-D659-47C8-9B49-16494E2ECF2A}"/>
+                <a16:creationId xmlns:a16="http://schemas.microsoft.com/office/drawing/2014/main" id="{8DE9E77C-4063-4BD4-AE3C-214E74030E32}"/>
               </a:ext>
             </a:extLst>
           </p:cNvPr>
@@ -14865,8 +15316,8 @@
         </p:nvSpPr>
         <p:spPr>
           <a:xfrm xmlns:a="http://schemas.openxmlformats.org/drawingml/2006/main">
-            <a:off x="7686675" y="1533525"/>
-            <a:ext cx="838200" cy="381000"/>
+            <a:off x="6200775" y="2400300"/>
+            <a:ext cx="838200" cy="342900"/>
           </a:xfrm>
           <a:prstGeom xmlns:a="http://schemas.openxmlformats.org/drawingml/2006/main" prst="rect">
             <a:avLst/>
@@ -15004,17 +15455,17 @@
                 <a:ea typeface="PingFang SC"/>
                 <a:cs typeface="PingFang SC"/>
               </a:rPr>
-              <a:t>11/10</a:t>
+              <a:t>11/6</a:t>
             </a:r>
           </a:p>
         </p:txBody>
       </p:sp>
       <p:sp>
         <p:nvSpPr>
-          <p:cNvPr id="10" name="">
+          <p:cNvPr id="11" name="">
             <a:extLst xmlns:a="http://schemas.openxmlformats.org/drawingml/2006/main">
               <a:ext uri="{FF2B5EF4-FFF2-40B4-BE49-F238E27FC236}">
-                <a16:creationId xmlns:a16="http://schemas.microsoft.com/office/drawing/2014/main" id="{0C603CF6-D169-4022-98B1-FA5C7AC6891F}"/>
+                <a16:creationId xmlns:a16="http://schemas.microsoft.com/office/drawing/2014/main" id="{1DE6C62D-F23C-490A-88B8-68A4059147F1}"/>
               </a:ext>
             </a:extLst>
           </p:cNvPr>
@@ -15025,8 +15476,8 @@
         </p:nvSpPr>
         <p:spPr>
           <a:xfrm xmlns:a="http://schemas.openxmlformats.org/drawingml/2006/main">
-            <a:off x="7953375" y="2009775"/>
-            <a:ext cx="0" cy="3419475"/>
+            <a:off x="6467475" y="2857500"/>
+            <a:ext cx="0" cy="2733675"/>
           </a:xfrm>
           <a:prstGeom xmlns:a="http://schemas.openxmlformats.org/drawingml/2006/main" prst="line">
             <a:avLst/>
@@ -15040,10 +15491,10 @@
       </p:sp>
       <p:sp>
         <p:nvSpPr>
-          <p:cNvPr id="11" name="">
+          <p:cNvPr id="12" name="">
             <a:extLst xmlns:a="http://schemas.openxmlformats.org/drawingml/2006/main">
               <a:ext uri="{FF2B5EF4-FFF2-40B4-BE49-F238E27FC236}">
-                <a16:creationId xmlns:a16="http://schemas.microsoft.com/office/drawing/2014/main" id="{6806DEC7-967A-4BD7-B6D0-BC475949DB36}"/>
+                <a16:creationId xmlns:a16="http://schemas.microsoft.com/office/drawing/2014/main" id="{5512AF57-4D0E-429E-9DF7-39ADC7D94E95}"/>
               </a:ext>
             </a:extLst>
           </p:cNvPr>
@@ -15054,8 +15505,8 @@
         </p:nvSpPr>
         <p:spPr>
           <a:xfrm xmlns:a="http://schemas.openxmlformats.org/drawingml/2006/main">
-            <a:off x="9544050" y="1533525"/>
-            <a:ext cx="838200" cy="381000"/>
+            <a:off x="7686675" y="2400300"/>
+            <a:ext cx="838200" cy="342900"/>
           </a:xfrm>
           <a:prstGeom xmlns:a="http://schemas.openxmlformats.org/drawingml/2006/main" prst="rect">
             <a:avLst/>
@@ -15193,17 +15644,17 @@
                 <a:ea typeface="PingFang SC"/>
                 <a:cs typeface="PingFang SC"/>
               </a:rPr>
-              <a:t>11/15</a:t>
+              <a:t>11/10</a:t>
             </a:r>
           </a:p>
         </p:txBody>
       </p:sp>
       <p:sp>
         <p:nvSpPr>
-          <p:cNvPr id="12" name="">
+          <p:cNvPr id="13" name="">
             <a:extLst xmlns:a="http://schemas.openxmlformats.org/drawingml/2006/main">
               <a:ext uri="{FF2B5EF4-FFF2-40B4-BE49-F238E27FC236}">
-                <a16:creationId xmlns:a16="http://schemas.microsoft.com/office/drawing/2014/main" id="{86BC10EC-AE3C-41C8-90E2-219EADE8A403}"/>
+                <a16:creationId xmlns:a16="http://schemas.microsoft.com/office/drawing/2014/main" id="{A8E13213-AA43-450B-9A30-12F6A1789D7A}"/>
               </a:ext>
             </a:extLst>
           </p:cNvPr>
@@ -15214,8 +15665,8 @@
         </p:nvSpPr>
         <p:spPr>
           <a:xfrm xmlns:a="http://schemas.openxmlformats.org/drawingml/2006/main">
-            <a:off x="9810750" y="2009775"/>
-            <a:ext cx="0" cy="3419475"/>
+            <a:off x="7953375" y="2857500"/>
+            <a:ext cx="0" cy="2733675"/>
           </a:xfrm>
           <a:prstGeom xmlns:a="http://schemas.openxmlformats.org/drawingml/2006/main" prst="line">
             <a:avLst/>
@@ -15229,10 +15680,10 @@
       </p:sp>
       <p:sp>
         <p:nvSpPr>
-          <p:cNvPr id="13" name="">
+          <p:cNvPr id="14" name="">
             <a:extLst xmlns:a="http://schemas.openxmlformats.org/drawingml/2006/main">
               <a:ext uri="{FF2B5EF4-FFF2-40B4-BE49-F238E27FC236}">
-                <a16:creationId xmlns:a16="http://schemas.microsoft.com/office/drawing/2014/main" id="{280997A9-EDCF-4914-92AD-3AAFDDBE3EB4}"/>
+                <a16:creationId xmlns:a16="http://schemas.microsoft.com/office/drawing/2014/main" id="{728F7463-4C30-423C-A724-957551BD9A7C}"/>
               </a:ext>
             </a:extLst>
           </p:cNvPr>
@@ -15243,8 +15694,8 @@
         </p:nvSpPr>
         <p:spPr>
           <a:xfrm xmlns:a="http://schemas.openxmlformats.org/drawingml/2006/main">
-            <a:off x="10658475" y="1533525"/>
-            <a:ext cx="838200" cy="381000"/>
+            <a:off x="9544050" y="2400300"/>
+            <a:ext cx="838200" cy="342900"/>
           </a:xfrm>
           <a:prstGeom xmlns:a="http://schemas.openxmlformats.org/drawingml/2006/main" prst="rect">
             <a:avLst/>
@@ -15382,17 +15833,17 @@
                 <a:ea typeface="PingFang SC"/>
                 <a:cs typeface="PingFang SC"/>
               </a:rPr>
-              <a:t>11/18</a:t>
+              <a:t>11/15</a:t>
             </a:r>
           </a:p>
         </p:txBody>
       </p:sp>
       <p:sp>
         <p:nvSpPr>
-          <p:cNvPr id="14" name="">
+          <p:cNvPr id="15" name="">
             <a:extLst xmlns:a="http://schemas.openxmlformats.org/drawingml/2006/main">
               <a:ext uri="{FF2B5EF4-FFF2-40B4-BE49-F238E27FC236}">
-                <a16:creationId xmlns:a16="http://schemas.microsoft.com/office/drawing/2014/main" id="{3543B6D3-01E1-42C5-BCE4-E8B3F123552F}"/>
+                <a16:creationId xmlns:a16="http://schemas.microsoft.com/office/drawing/2014/main" id="{92C1AAFA-6B93-4F93-BD40-D8DDC23E03D6}"/>
               </a:ext>
             </a:extLst>
           </p:cNvPr>
@@ -15403,8 +15854,8 @@
         </p:nvSpPr>
         <p:spPr>
           <a:xfrm xmlns:a="http://schemas.openxmlformats.org/drawingml/2006/main">
-            <a:off x="10925175" y="2009775"/>
-            <a:ext cx="0" cy="3419475"/>
+            <a:off x="9810750" y="2857500"/>
+            <a:ext cx="0" cy="2733675"/>
           </a:xfrm>
           <a:prstGeom xmlns:a="http://schemas.openxmlformats.org/drawingml/2006/main" prst="line">
             <a:avLst/>
@@ -15418,10 +15869,10 @@
       </p:sp>
       <p:sp>
         <p:nvSpPr>
-          <p:cNvPr id="15" name="">
+          <p:cNvPr id="16" name="">
             <a:extLst xmlns:a="http://schemas.openxmlformats.org/drawingml/2006/main">
               <a:ext uri="{FF2B5EF4-FFF2-40B4-BE49-F238E27FC236}">
-                <a16:creationId xmlns:a16="http://schemas.microsoft.com/office/drawing/2014/main" id="{B3835B08-7246-445B-82C2-102BB5AF0612}"/>
+                <a16:creationId xmlns:a16="http://schemas.microsoft.com/office/drawing/2014/main" id="{8113CB11-C20F-4890-BBE8-214DAB95C048}"/>
               </a:ext>
             </a:extLst>
           </p:cNvPr>
@@ -15432,8 +15883,8 @@
         </p:nvSpPr>
         <p:spPr>
           <a:xfrm xmlns:a="http://schemas.openxmlformats.org/drawingml/2006/main">
-            <a:off x="638175" y="2143125"/>
-            <a:ext cx="2695575" cy="409575"/>
+            <a:off x="10658475" y="2400300"/>
+            <a:ext cx="838200" cy="342900"/>
           </a:xfrm>
           <a:prstGeom xmlns:a="http://schemas.openxmlformats.org/drawingml/2006/main" prst="rect">
             <a:avLst/>
@@ -15447,9 +15898,9 @@
           <a:bodyPr xmlns:a="http://schemas.openxmlformats.org/drawingml/2006/main" wrap="square" lIns="0" tIns="0" rIns="0" bIns="0" anchor="t"/>
           <a:lstStyle xmlns:a="http://schemas.openxmlformats.org/drawingml/2006/main">
             <a:defPPr algn="l">
-              <a:defRPr sz="1950" b="0">
-                <a:solidFill>
-                  <a:srgbClr val="222D32"/>
+              <a:defRPr sz="1725" b="0">
+                <a:solidFill>
+                  <a:srgbClr val="667274"/>
                 </a:solidFill>
                 <a:latin typeface="PingFang SC"/>
                 <a:ea typeface="PingFang SC"/>
@@ -15457,9 +15908,9 @@
               </a:defRPr>
             </a:defPPr>
             <a:lvl1pPr algn="l">
-              <a:defRPr sz="1950" b="0">
-                <a:solidFill>
-                  <a:srgbClr val="222D32"/>
+              <a:defRPr sz="1725" b="0">
+                <a:solidFill>
+                  <a:srgbClr val="667274"/>
                 </a:solidFill>
                 <a:latin typeface="PingFang SC"/>
                 <a:ea typeface="PingFang SC"/>
@@ -15467,9 +15918,9 @@
               </a:defRPr>
             </a:lvl1pPr>
             <a:lvl2pPr algn="l">
-              <a:defRPr sz="1950" b="0">
-                <a:solidFill>
-                  <a:srgbClr val="222D32"/>
+              <a:defRPr sz="1725" b="0">
+                <a:solidFill>
+                  <a:srgbClr val="667274"/>
                 </a:solidFill>
                 <a:latin typeface="PingFang SC"/>
                 <a:ea typeface="PingFang SC"/>
@@ -15477,9 +15928,9 @@
               </a:defRPr>
             </a:lvl2pPr>
             <a:lvl3pPr algn="l">
-              <a:defRPr sz="1950" b="0">
-                <a:solidFill>
-                  <a:srgbClr val="222D32"/>
+              <a:defRPr sz="1725" b="0">
+                <a:solidFill>
+                  <a:srgbClr val="667274"/>
                 </a:solidFill>
                 <a:latin typeface="PingFang SC"/>
                 <a:ea typeface="PingFang SC"/>
@@ -15487,9 +15938,9 @@
               </a:defRPr>
             </a:lvl3pPr>
             <a:lvl4pPr algn="l">
-              <a:defRPr sz="1950" b="0">
-                <a:solidFill>
-                  <a:srgbClr val="222D32"/>
+              <a:defRPr sz="1725" b="0">
+                <a:solidFill>
+                  <a:srgbClr val="667274"/>
                 </a:solidFill>
                 <a:latin typeface="PingFang SC"/>
                 <a:ea typeface="PingFang SC"/>
@@ -15497,9 +15948,9 @@
               </a:defRPr>
             </a:lvl4pPr>
             <a:lvl5pPr algn="l">
-              <a:defRPr sz="1950" b="0">
-                <a:solidFill>
-                  <a:srgbClr val="222D32"/>
+              <a:defRPr sz="1725" b="0">
+                <a:solidFill>
+                  <a:srgbClr val="667274"/>
                 </a:solidFill>
                 <a:latin typeface="PingFang SC"/>
                 <a:ea typeface="PingFang SC"/>
@@ -15507,9 +15958,9 @@
               </a:defRPr>
             </a:lvl5pPr>
             <a:lvl6pPr algn="l">
-              <a:defRPr sz="1950" b="0">
-                <a:solidFill>
-                  <a:srgbClr val="222D32"/>
+              <a:defRPr sz="1725" b="0">
+                <a:solidFill>
+                  <a:srgbClr val="667274"/>
                 </a:solidFill>
                 <a:latin typeface="PingFang SC"/>
                 <a:ea typeface="PingFang SC"/>
@@ -15517,9 +15968,9 @@
               </a:defRPr>
             </a:lvl6pPr>
             <a:lvl7pPr algn="l">
-              <a:defRPr sz="1950" b="0">
-                <a:solidFill>
-                  <a:srgbClr val="222D32"/>
+              <a:defRPr sz="1725" b="0">
+                <a:solidFill>
+                  <a:srgbClr val="667274"/>
                 </a:solidFill>
                 <a:latin typeface="PingFang SC"/>
                 <a:ea typeface="PingFang SC"/>
@@ -15527,9 +15978,9 @@
               </a:defRPr>
             </a:lvl7pPr>
             <a:lvl8pPr algn="l">
-              <a:defRPr sz="1950" b="0">
-                <a:solidFill>
-                  <a:srgbClr val="222D32"/>
+              <a:defRPr sz="1725" b="0">
+                <a:solidFill>
+                  <a:srgbClr val="667274"/>
                 </a:solidFill>
                 <a:latin typeface="PingFang SC"/>
                 <a:ea typeface="PingFang SC"/>
@@ -15537,9 +15988,9 @@
               </a:defRPr>
             </a:lvl8pPr>
             <a:lvl9pPr algn="l">
-              <a:defRPr sz="1950" b="0">
-                <a:solidFill>
-                  <a:srgbClr val="222D32"/>
+              <a:defRPr sz="1725" b="0">
+                <a:solidFill>
+                  <a:srgbClr val="667274"/>
                 </a:solidFill>
                 <a:latin typeface="PingFang SC"/>
                 <a:ea typeface="PingFang SC"/>
@@ -15553,9 +16004,9 @@
                 <a:spcPct val="118000"/>
               </a:lnSpc>
               <a:buNone/>
-              <a:defRPr sz="1950" b="0">
-                <a:solidFill>
-                  <a:srgbClr val="222D32"/>
+              <a:defRPr sz="1725" b="0">
+                <a:solidFill>
+                  <a:srgbClr val="667274"/>
                 </a:solidFill>
                 <a:latin typeface="PingFang SC"/>
                 <a:ea typeface="PingFang SC"/>
@@ -15563,25 +16014,25 @@
               </a:defRPr>
             </a:pPr>
             <a:r>
-              <a:rPr sz="1950" b="0">
-                <a:solidFill>
-                  <a:srgbClr val="222D32"/>
+              <a:rPr sz="1725" b="0">
+                <a:solidFill>
+                  <a:srgbClr val="667274"/>
                 </a:solidFill>
                 <a:latin typeface="PingFang SC"/>
                 <a:ea typeface="PingFang SC"/>
                 <a:cs typeface="PingFang SC"/>
               </a:rPr>
-              <a:t>接手与复现</a:t>
+              <a:t>11/18</a:t>
             </a:r>
           </a:p>
         </p:txBody>
       </p:sp>
       <p:sp>
         <p:nvSpPr>
-          <p:cNvPr id="16" name="">
+          <p:cNvPr id="17" name="">
             <a:extLst xmlns:a="http://schemas.openxmlformats.org/drawingml/2006/main">
               <a:ext uri="{FF2B5EF4-FFF2-40B4-BE49-F238E27FC236}">
-                <a16:creationId xmlns:a16="http://schemas.microsoft.com/office/drawing/2014/main" id="{05D3FB68-914F-4CF1-87CF-AA0D061562C0}"/>
+                <a16:creationId xmlns:a16="http://schemas.microsoft.com/office/drawing/2014/main" id="{F45B4836-D420-44CF-962C-C0F3638D5AAC}"/>
               </a:ext>
             </a:extLst>
           </p:cNvPr>
@@ -15592,8 +16043,197 @@
         </p:nvSpPr>
         <p:spPr>
           <a:xfrm xmlns:a="http://schemas.openxmlformats.org/drawingml/2006/main">
-            <a:off x="3495675" y="2190750"/>
-            <a:ext cx="1066800" cy="285750"/>
+            <a:off x="10925175" y="2857500"/>
+            <a:ext cx="0" cy="2733675"/>
+          </a:xfrm>
+          <a:prstGeom xmlns:a="http://schemas.openxmlformats.org/drawingml/2006/main" prst="line">
+            <a:avLst/>
+          </a:prstGeom>
+          <a:ln xmlns:a="http://schemas.openxmlformats.org/drawingml/2006/main" w="9525">
+            <a:solidFill>
+              <a:srgbClr val="DDE2DF"/>
+            </a:solidFill>
+          </a:ln>
+        </p:spPr>
+      </p:sp>
+      <p:sp>
+        <p:nvSpPr>
+          <p:cNvPr id="18" name="">
+            <a:extLst xmlns:a="http://schemas.openxmlformats.org/drawingml/2006/main">
+              <a:ext uri="{FF2B5EF4-FFF2-40B4-BE49-F238E27FC236}">
+                <a16:creationId xmlns:a16="http://schemas.microsoft.com/office/drawing/2014/main" id="{F7332E71-E4C6-4687-8F99-D39F785BB5C2}"/>
+              </a:ext>
+            </a:extLst>
+          </p:cNvPr>
+          <p:cNvSpPr>
+            <a:spLocks xmlns:a="http://schemas.openxmlformats.org/drawingml/2006/main" noGrp="1"/>
+          </p:cNvSpPr>
+          <p:nvPr/>
+        </p:nvSpPr>
+        <p:spPr>
+          <a:xfrm xmlns:a="http://schemas.openxmlformats.org/drawingml/2006/main">
+            <a:off x="638175" y="2990850"/>
+            <a:ext cx="2695575" cy="371475"/>
+          </a:xfrm>
+          <a:prstGeom xmlns:a="http://schemas.openxmlformats.org/drawingml/2006/main" prst="rect">
+            <a:avLst/>
+          </a:prstGeom>
+          <a:noFill xmlns:a="http://schemas.openxmlformats.org/drawingml/2006/main"/>
+          <a:ln xmlns:a="http://schemas.openxmlformats.org/drawingml/2006/main" w="0">
+            <a:noFill/>
+          </a:ln>
+        </p:spPr>
+        <p:txBody>
+          <a:bodyPr xmlns:a="http://schemas.openxmlformats.org/drawingml/2006/main" wrap="square" lIns="0" tIns="0" rIns="0" bIns="0" anchor="t"/>
+          <a:lstStyle xmlns:a="http://schemas.openxmlformats.org/drawingml/2006/main">
+            <a:defPPr algn="l">
+              <a:defRPr sz="1875" b="0">
+                <a:solidFill>
+                  <a:srgbClr val="222D32"/>
+                </a:solidFill>
+                <a:latin typeface="PingFang SC"/>
+                <a:ea typeface="PingFang SC"/>
+                <a:cs typeface="PingFang SC"/>
+              </a:defRPr>
+            </a:defPPr>
+            <a:lvl1pPr algn="l">
+              <a:defRPr sz="1875" b="0">
+                <a:solidFill>
+                  <a:srgbClr val="222D32"/>
+                </a:solidFill>
+                <a:latin typeface="PingFang SC"/>
+                <a:ea typeface="PingFang SC"/>
+                <a:cs typeface="PingFang SC"/>
+              </a:defRPr>
+            </a:lvl1pPr>
+            <a:lvl2pPr algn="l">
+              <a:defRPr sz="1875" b="0">
+                <a:solidFill>
+                  <a:srgbClr val="222D32"/>
+                </a:solidFill>
+                <a:latin typeface="PingFang SC"/>
+                <a:ea typeface="PingFang SC"/>
+                <a:cs typeface="PingFang SC"/>
+              </a:defRPr>
+            </a:lvl2pPr>
+            <a:lvl3pPr algn="l">
+              <a:defRPr sz="1875" b="0">
+                <a:solidFill>
+                  <a:srgbClr val="222D32"/>
+                </a:solidFill>
+                <a:latin typeface="PingFang SC"/>
+                <a:ea typeface="PingFang SC"/>
+                <a:cs typeface="PingFang SC"/>
+              </a:defRPr>
+            </a:lvl3pPr>
+            <a:lvl4pPr algn="l">
+              <a:defRPr sz="1875" b="0">
+                <a:solidFill>
+                  <a:srgbClr val="222D32"/>
+                </a:solidFill>
+                <a:latin typeface="PingFang SC"/>
+                <a:ea typeface="PingFang SC"/>
+                <a:cs typeface="PingFang SC"/>
+              </a:defRPr>
+            </a:lvl4pPr>
+            <a:lvl5pPr algn="l">
+              <a:defRPr sz="1875" b="0">
+                <a:solidFill>
+                  <a:srgbClr val="222D32"/>
+                </a:solidFill>
+                <a:latin typeface="PingFang SC"/>
+                <a:ea typeface="PingFang SC"/>
+                <a:cs typeface="PingFang SC"/>
+              </a:defRPr>
+            </a:lvl5pPr>
+            <a:lvl6pPr algn="l">
+              <a:defRPr sz="1875" b="0">
+                <a:solidFill>
+                  <a:srgbClr val="222D32"/>
+                </a:solidFill>
+                <a:latin typeface="PingFang SC"/>
+                <a:ea typeface="PingFang SC"/>
+                <a:cs typeface="PingFang SC"/>
+              </a:defRPr>
+            </a:lvl6pPr>
+            <a:lvl7pPr algn="l">
+              <a:defRPr sz="1875" b="0">
+                <a:solidFill>
+                  <a:srgbClr val="222D32"/>
+                </a:solidFill>
+                <a:latin typeface="PingFang SC"/>
+                <a:ea typeface="PingFang SC"/>
+                <a:cs typeface="PingFang SC"/>
+              </a:defRPr>
+            </a:lvl7pPr>
+            <a:lvl8pPr algn="l">
+              <a:defRPr sz="1875" b="0">
+                <a:solidFill>
+                  <a:srgbClr val="222D32"/>
+                </a:solidFill>
+                <a:latin typeface="PingFang SC"/>
+                <a:ea typeface="PingFang SC"/>
+                <a:cs typeface="PingFang SC"/>
+              </a:defRPr>
+            </a:lvl8pPr>
+            <a:lvl9pPr algn="l">
+              <a:defRPr sz="1875" b="0">
+                <a:solidFill>
+                  <a:srgbClr val="222D32"/>
+                </a:solidFill>
+                <a:latin typeface="PingFang SC"/>
+                <a:ea typeface="PingFang SC"/>
+                <a:cs typeface="PingFang SC"/>
+              </a:defRPr>
+            </a:lvl9pPr>
+          </a:lstStyle>
+          <a:p xmlns:a="http://schemas.openxmlformats.org/drawingml/2006/main">
+            <a:pPr algn="l">
+              <a:lnSpc>
+                <a:spcPct val="118000"/>
+              </a:lnSpc>
+              <a:buNone/>
+              <a:defRPr sz="1875" b="0">
+                <a:solidFill>
+                  <a:srgbClr val="222D32"/>
+                </a:solidFill>
+                <a:latin typeface="PingFang SC"/>
+                <a:ea typeface="PingFang SC"/>
+                <a:cs typeface="PingFang SC"/>
+              </a:defRPr>
+            </a:pPr>
+            <a:r>
+              <a:rPr sz="1875" b="0">
+                <a:solidFill>
+                  <a:srgbClr val="222D32"/>
+                </a:solidFill>
+                <a:latin typeface="PingFang SC"/>
+                <a:ea typeface="PingFang SC"/>
+                <a:cs typeface="PingFang SC"/>
+              </a:rPr>
+              <a:t>接手与复现</a:t>
+            </a:r>
+          </a:p>
+        </p:txBody>
+      </p:sp>
+      <p:sp>
+        <p:nvSpPr>
+          <p:cNvPr id="19" name="">
+            <a:extLst xmlns:a="http://schemas.openxmlformats.org/drawingml/2006/main">
+              <a:ext uri="{FF2B5EF4-FFF2-40B4-BE49-F238E27FC236}">
+                <a16:creationId xmlns:a16="http://schemas.microsoft.com/office/drawing/2014/main" id="{CE048B38-C0A9-4F6A-A8F3-F2DF00193AD2}"/>
+              </a:ext>
+            </a:extLst>
+          </p:cNvPr>
+          <p:cNvSpPr>
+            <a:spLocks xmlns:a="http://schemas.openxmlformats.org/drawingml/2006/main" noGrp="1"/>
+          </p:cNvSpPr>
+          <p:nvPr/>
+        </p:nvSpPr>
+        <p:spPr>
+          <a:xfrm xmlns:a="http://schemas.openxmlformats.org/drawingml/2006/main">
+            <a:off x="3495675" y="3038475"/>
+            <a:ext cx="1066800" cy="257175"/>
           </a:xfrm>
           <a:prstGeom xmlns:a="http://schemas.openxmlformats.org/drawingml/2006/main" prst="rect">
             <a:avLst/>
@@ -15608,10 +16248,10 @@
       </p:sp>
       <p:sp>
         <p:nvSpPr>
-          <p:cNvPr id="17" name="">
+          <p:cNvPr id="20" name="">
             <a:extLst xmlns:a="http://schemas.openxmlformats.org/drawingml/2006/main">
               <a:ext uri="{FF2B5EF4-FFF2-40B4-BE49-F238E27FC236}">
-                <a16:creationId xmlns:a16="http://schemas.microsoft.com/office/drawing/2014/main" id="{2A35DB0F-0847-451E-AE93-721A5E6C4022}"/>
+                <a16:creationId xmlns:a16="http://schemas.microsoft.com/office/drawing/2014/main" id="{440CCEFF-3132-4ECD-996F-D45FC32EF6A9}"/>
               </a:ext>
             </a:extLst>
           </p:cNvPr>
@@ -15622,8 +16262,8 @@
         </p:nvSpPr>
         <p:spPr>
           <a:xfrm xmlns:a="http://schemas.openxmlformats.org/drawingml/2006/main">
-            <a:off x="638175" y="2809875"/>
-            <a:ext cx="2695575" cy="409575"/>
+            <a:off x="638175" y="3495675"/>
+            <a:ext cx="2695575" cy="371475"/>
           </a:xfrm>
           <a:prstGeom xmlns:a="http://schemas.openxmlformats.org/drawingml/2006/main" prst="rect">
             <a:avLst/>
@@ -15637,7 +16277,7 @@
           <a:bodyPr xmlns:a="http://schemas.openxmlformats.org/drawingml/2006/main" wrap="square" lIns="0" tIns="0" rIns="0" bIns="0" anchor="t"/>
           <a:lstStyle xmlns:a="http://schemas.openxmlformats.org/drawingml/2006/main">
             <a:defPPr algn="l">
-              <a:defRPr sz="1950" b="0">
+              <a:defRPr sz="1875" b="0">
                 <a:solidFill>
                   <a:srgbClr val="222D32"/>
                 </a:solidFill>
@@ -15647,7 +16287,7 @@
               </a:defRPr>
             </a:defPPr>
             <a:lvl1pPr algn="l">
-              <a:defRPr sz="1950" b="0">
+              <a:defRPr sz="1875" b="0">
                 <a:solidFill>
                   <a:srgbClr val="222D32"/>
                 </a:solidFill>
@@ -15657,7 +16297,7 @@
               </a:defRPr>
             </a:lvl1pPr>
             <a:lvl2pPr algn="l">
-              <a:defRPr sz="1950" b="0">
+              <a:defRPr sz="1875" b="0">
                 <a:solidFill>
                   <a:srgbClr val="222D32"/>
                 </a:solidFill>
@@ -15667,7 +16307,7 @@
               </a:defRPr>
             </a:lvl2pPr>
             <a:lvl3pPr algn="l">
-              <a:defRPr sz="1950" b="0">
+              <a:defRPr sz="1875" b="0">
                 <a:solidFill>
                   <a:srgbClr val="222D32"/>
                 </a:solidFill>
@@ -15677,7 +16317,7 @@
               </a:defRPr>
             </a:lvl3pPr>
             <a:lvl4pPr algn="l">
-              <a:defRPr sz="1950" b="0">
+              <a:defRPr sz="1875" b="0">
                 <a:solidFill>
                   <a:srgbClr val="222D32"/>
                 </a:solidFill>
@@ -15687,7 +16327,7 @@
               </a:defRPr>
             </a:lvl4pPr>
             <a:lvl5pPr algn="l">
-              <a:defRPr sz="1950" b="0">
+              <a:defRPr sz="1875" b="0">
                 <a:solidFill>
                   <a:srgbClr val="222D32"/>
                 </a:solidFill>
@@ -15697,7 +16337,7 @@
               </a:defRPr>
             </a:lvl5pPr>
             <a:lvl6pPr algn="l">
-              <a:defRPr sz="1950" b="0">
+              <a:defRPr sz="1875" b="0">
                 <a:solidFill>
                   <a:srgbClr val="222D32"/>
                 </a:solidFill>
@@ -15707,7 +16347,7 @@
               </a:defRPr>
             </a:lvl6pPr>
             <a:lvl7pPr algn="l">
-              <a:defRPr sz="1950" b="0">
+              <a:defRPr sz="1875" b="0">
                 <a:solidFill>
                   <a:srgbClr val="222D32"/>
                 </a:solidFill>
@@ -15717,7 +16357,7 @@
               </a:defRPr>
             </a:lvl7pPr>
             <a:lvl8pPr algn="l">
-              <a:defRPr sz="1950" b="0">
+              <a:defRPr sz="1875" b="0">
                 <a:solidFill>
                   <a:srgbClr val="222D32"/>
                 </a:solidFill>
@@ -15727,7 +16367,7 @@
               </a:defRPr>
             </a:lvl8pPr>
             <a:lvl9pPr algn="l">
-              <a:defRPr sz="1950" b="0">
+              <a:defRPr sz="1875" b="0">
                 <a:solidFill>
                   <a:srgbClr val="222D32"/>
                 </a:solidFill>
@@ -15743,7 +16383,7 @@
                 <a:spcPct val="118000"/>
               </a:lnSpc>
               <a:buNone/>
-              <a:defRPr sz="1950" b="0">
+              <a:defRPr sz="1875" b="0">
                 <a:solidFill>
                   <a:srgbClr val="222D32"/>
                 </a:solidFill>
@@ -15753,7 +16393,7 @@
               </a:defRPr>
             </a:pPr>
             <a:r>
-              <a:rPr sz="1950" b="0">
+              <a:rPr sz="1875" b="0">
                 <a:solidFill>
                   <a:srgbClr val="222D32"/>
                 </a:solidFill>
@@ -15768,10 +16408,10 @@
       </p:sp>
       <p:sp>
         <p:nvSpPr>
-          <p:cNvPr id="18" name="">
+          <p:cNvPr id="21" name="">
             <a:extLst xmlns:a="http://schemas.openxmlformats.org/drawingml/2006/main">
               <a:ext uri="{FF2B5EF4-FFF2-40B4-BE49-F238E27FC236}">
-                <a16:creationId xmlns:a16="http://schemas.microsoft.com/office/drawing/2014/main" id="{65534A4D-73C8-4CDE-AFA8-FFA9B33F5ADA}"/>
+                <a16:creationId xmlns:a16="http://schemas.microsoft.com/office/drawing/2014/main" id="{C7806A8F-5486-4B69-A515-2512F155EEFD}"/>
               </a:ext>
             </a:extLst>
           </p:cNvPr>
@@ -15782,8 +16422,8 @@
         </p:nvSpPr>
         <p:spPr>
           <a:xfrm xmlns:a="http://schemas.openxmlformats.org/drawingml/2006/main">
-            <a:off x="4610100" y="2857500"/>
-            <a:ext cx="1809750" cy="285750"/>
+            <a:off x="4610100" y="3543300"/>
+            <a:ext cx="1809750" cy="257175"/>
           </a:xfrm>
           <a:prstGeom xmlns:a="http://schemas.openxmlformats.org/drawingml/2006/main" prst="rect">
             <a:avLst/>
@@ -15798,10 +16438,10 @@
       </p:sp>
       <p:sp>
         <p:nvSpPr>
-          <p:cNvPr id="19" name="">
+          <p:cNvPr id="22" name="">
             <a:extLst xmlns:a="http://schemas.openxmlformats.org/drawingml/2006/main">
               <a:ext uri="{FF2B5EF4-FFF2-40B4-BE49-F238E27FC236}">
-                <a16:creationId xmlns:a16="http://schemas.microsoft.com/office/drawing/2014/main" id="{DAAF66E0-18AA-469A-90FA-259228C71725}"/>
+                <a16:creationId xmlns:a16="http://schemas.microsoft.com/office/drawing/2014/main" id="{0FC174BD-481E-4ABC-B360-066FE93C9991}"/>
               </a:ext>
             </a:extLst>
           </p:cNvPr>
@@ -15812,8 +16452,8 @@
         </p:nvSpPr>
         <p:spPr>
           <a:xfrm xmlns:a="http://schemas.openxmlformats.org/drawingml/2006/main">
-            <a:off x="638175" y="3476625"/>
-            <a:ext cx="2695575" cy="409575"/>
+            <a:off x="638175" y="4000500"/>
+            <a:ext cx="2695575" cy="371475"/>
           </a:xfrm>
           <a:prstGeom xmlns:a="http://schemas.openxmlformats.org/drawingml/2006/main" prst="rect">
             <a:avLst/>
@@ -15827,7 +16467,7 @@
           <a:bodyPr xmlns:a="http://schemas.openxmlformats.org/drawingml/2006/main" wrap="square" lIns="0" tIns="0" rIns="0" bIns="0" anchor="t"/>
           <a:lstStyle xmlns:a="http://schemas.openxmlformats.org/drawingml/2006/main">
             <a:defPPr algn="l">
-              <a:defRPr sz="1950" b="0">
+              <a:defRPr sz="1875" b="0">
                 <a:solidFill>
                   <a:srgbClr val="222D32"/>
                 </a:solidFill>
@@ -15837,7 +16477,7 @@
               </a:defRPr>
             </a:defPPr>
             <a:lvl1pPr algn="l">
-              <a:defRPr sz="1950" b="0">
+              <a:defRPr sz="1875" b="0">
                 <a:solidFill>
                   <a:srgbClr val="222D32"/>
                 </a:solidFill>
@@ -15847,7 +16487,7 @@
               </a:defRPr>
             </a:lvl1pPr>
             <a:lvl2pPr algn="l">
-              <a:defRPr sz="1950" b="0">
+              <a:defRPr sz="1875" b="0">
                 <a:solidFill>
                   <a:srgbClr val="222D32"/>
                 </a:solidFill>
@@ -15857,7 +16497,7 @@
               </a:defRPr>
             </a:lvl2pPr>
             <a:lvl3pPr algn="l">
-              <a:defRPr sz="1950" b="0">
+              <a:defRPr sz="1875" b="0">
                 <a:solidFill>
                   <a:srgbClr val="222D32"/>
                 </a:solidFill>
@@ -15867,7 +16507,7 @@
               </a:defRPr>
             </a:lvl3pPr>
             <a:lvl4pPr algn="l">
-              <a:defRPr sz="1950" b="0">
+              <a:defRPr sz="1875" b="0">
                 <a:solidFill>
                   <a:srgbClr val="222D32"/>
                 </a:solidFill>
@@ -15877,7 +16517,7 @@
               </a:defRPr>
             </a:lvl4pPr>
             <a:lvl5pPr algn="l">
-              <a:defRPr sz="1950" b="0">
+              <a:defRPr sz="1875" b="0">
                 <a:solidFill>
                   <a:srgbClr val="222D32"/>
                 </a:solidFill>
@@ -15887,7 +16527,7 @@
               </a:defRPr>
             </a:lvl5pPr>
             <a:lvl6pPr algn="l">
-              <a:defRPr sz="1950" b="0">
+              <a:defRPr sz="1875" b="0">
                 <a:solidFill>
                   <a:srgbClr val="222D32"/>
                 </a:solidFill>
@@ -15897,7 +16537,7 @@
               </a:defRPr>
             </a:lvl6pPr>
             <a:lvl7pPr algn="l">
-              <a:defRPr sz="1950" b="0">
+              <a:defRPr sz="1875" b="0">
                 <a:solidFill>
                   <a:srgbClr val="222D32"/>
                 </a:solidFill>
@@ -15907,7 +16547,7 @@
               </a:defRPr>
             </a:lvl7pPr>
             <a:lvl8pPr algn="l">
-              <a:defRPr sz="1950" b="0">
+              <a:defRPr sz="1875" b="0">
                 <a:solidFill>
                   <a:srgbClr val="222D32"/>
                 </a:solidFill>
@@ -15917,7 +16557,7 @@
               </a:defRPr>
             </a:lvl8pPr>
             <a:lvl9pPr algn="l">
-              <a:defRPr sz="1950" b="0">
+              <a:defRPr sz="1875" b="0">
                 <a:solidFill>
                   <a:srgbClr val="222D32"/>
                 </a:solidFill>
@@ -15933,7 +16573,7 @@
                 <a:spcPct val="118000"/>
               </a:lnSpc>
               <a:buNone/>
-              <a:defRPr sz="1950" b="0">
+              <a:defRPr sz="1875" b="0">
                 <a:solidFill>
                   <a:srgbClr val="222D32"/>
                 </a:solidFill>
@@ -15943,7 +16583,7 @@
               </a:defRPr>
             </a:pPr>
             <a:r>
-              <a:rPr sz="1950" b="0">
+              <a:rPr sz="1875" b="0">
                 <a:solidFill>
                   <a:srgbClr val="222D32"/>
                 </a:solidFill>
@@ -15958,10 +16598,10 @@
       </p:sp>
       <p:sp>
         <p:nvSpPr>
-          <p:cNvPr id="20" name="">
+          <p:cNvPr id="23" name="">
             <a:extLst xmlns:a="http://schemas.openxmlformats.org/drawingml/2006/main">
               <a:ext uri="{FF2B5EF4-FFF2-40B4-BE49-F238E27FC236}">
-                <a16:creationId xmlns:a16="http://schemas.microsoft.com/office/drawing/2014/main" id="{B344D652-4B31-4239-A893-843CBEFA73B8}"/>
+                <a16:creationId xmlns:a16="http://schemas.microsoft.com/office/drawing/2014/main" id="{0CE24A6D-B0E2-4A3C-A7C4-CCB04EFCBF5F}"/>
               </a:ext>
             </a:extLst>
           </p:cNvPr>
@@ -15972,8 +16612,8 @@
         </p:nvSpPr>
         <p:spPr>
           <a:xfrm xmlns:a="http://schemas.openxmlformats.org/drawingml/2006/main">
-            <a:off x="6467475" y="3524250"/>
-            <a:ext cx="1438275" cy="285750"/>
+            <a:off x="6467475" y="4048125"/>
+            <a:ext cx="1438275" cy="257175"/>
           </a:xfrm>
           <a:prstGeom xmlns:a="http://schemas.openxmlformats.org/drawingml/2006/main" prst="rect">
             <a:avLst/>
@@ -15988,10 +16628,10 @@
       </p:sp>
       <p:sp>
         <p:nvSpPr>
-          <p:cNvPr id="21" name="">
+          <p:cNvPr id="24" name="">
             <a:extLst xmlns:a="http://schemas.openxmlformats.org/drawingml/2006/main">
               <a:ext uri="{FF2B5EF4-FFF2-40B4-BE49-F238E27FC236}">
-                <a16:creationId xmlns:a16="http://schemas.microsoft.com/office/drawing/2014/main" id="{2188D183-8EA6-4A0C-A553-F577A36F153E}"/>
+                <a16:creationId xmlns:a16="http://schemas.microsoft.com/office/drawing/2014/main" id="{5C6E0E76-75DC-452B-BBBF-137707F71107}"/>
               </a:ext>
             </a:extLst>
           </p:cNvPr>
@@ -16002,8 +16642,8 @@
         </p:nvSpPr>
         <p:spPr>
           <a:xfrm xmlns:a="http://schemas.openxmlformats.org/drawingml/2006/main">
-            <a:off x="638175" y="4143375"/>
-            <a:ext cx="2695575" cy="409575"/>
+            <a:off x="638175" y="4505325"/>
+            <a:ext cx="2695575" cy="371475"/>
           </a:xfrm>
           <a:prstGeom xmlns:a="http://schemas.openxmlformats.org/drawingml/2006/main" prst="rect">
             <a:avLst/>
@@ -16017,7 +16657,7 @@
           <a:bodyPr xmlns:a="http://schemas.openxmlformats.org/drawingml/2006/main" wrap="square" lIns="0" tIns="0" rIns="0" bIns="0" anchor="t"/>
           <a:lstStyle xmlns:a="http://schemas.openxmlformats.org/drawingml/2006/main">
             <a:defPPr algn="l">
-              <a:defRPr sz="1950" b="0">
+              <a:defRPr sz="1875" b="0">
                 <a:solidFill>
                   <a:srgbClr val="222D32"/>
                 </a:solidFill>
@@ -16027,7 +16667,7 @@
               </a:defRPr>
             </a:defPPr>
             <a:lvl1pPr algn="l">
-              <a:defRPr sz="1950" b="0">
+              <a:defRPr sz="1875" b="0">
                 <a:solidFill>
                   <a:srgbClr val="222D32"/>
                 </a:solidFill>
@@ -16037,7 +16677,7 @@
               </a:defRPr>
             </a:lvl1pPr>
             <a:lvl2pPr algn="l">
-              <a:defRPr sz="1950" b="0">
+              <a:defRPr sz="1875" b="0">
                 <a:solidFill>
                   <a:srgbClr val="222D32"/>
                 </a:solidFill>
@@ -16047,7 +16687,7 @@
               </a:defRPr>
             </a:lvl2pPr>
             <a:lvl3pPr algn="l">
-              <a:defRPr sz="1950" b="0">
+              <a:defRPr sz="1875" b="0">
                 <a:solidFill>
                   <a:srgbClr val="222D32"/>
                 </a:solidFill>
@@ -16057,7 +16697,7 @@
               </a:defRPr>
             </a:lvl3pPr>
             <a:lvl4pPr algn="l">
-              <a:defRPr sz="1950" b="0">
+              <a:defRPr sz="1875" b="0">
                 <a:solidFill>
                   <a:srgbClr val="222D32"/>
                 </a:solidFill>
@@ -16067,7 +16707,7 @@
               </a:defRPr>
             </a:lvl4pPr>
             <a:lvl5pPr algn="l">
-              <a:defRPr sz="1950" b="0">
+              <a:defRPr sz="1875" b="0">
                 <a:solidFill>
                   <a:srgbClr val="222D32"/>
                 </a:solidFill>
@@ -16077,7 +16717,7 @@
               </a:defRPr>
             </a:lvl5pPr>
             <a:lvl6pPr algn="l">
-              <a:defRPr sz="1950" b="0">
+              <a:defRPr sz="1875" b="0">
                 <a:solidFill>
                   <a:srgbClr val="222D32"/>
                 </a:solidFill>
@@ -16087,7 +16727,7 @@
               </a:defRPr>
             </a:lvl6pPr>
             <a:lvl7pPr algn="l">
-              <a:defRPr sz="1950" b="0">
+              <a:defRPr sz="1875" b="0">
                 <a:solidFill>
                   <a:srgbClr val="222D32"/>
                 </a:solidFill>
@@ -16097,7 +16737,7 @@
               </a:defRPr>
             </a:lvl7pPr>
             <a:lvl8pPr algn="l">
-              <a:defRPr sz="1950" b="0">
+              <a:defRPr sz="1875" b="0">
                 <a:solidFill>
                   <a:srgbClr val="222D32"/>
                 </a:solidFill>
@@ -16107,7 +16747,7 @@
               </a:defRPr>
             </a:lvl8pPr>
             <a:lvl9pPr algn="l">
-              <a:defRPr sz="1950" b="0">
+              <a:defRPr sz="1875" b="0">
                 <a:solidFill>
                   <a:srgbClr val="222D32"/>
                 </a:solidFill>
@@ -16123,7 +16763,7 @@
                 <a:spcPct val="118000"/>
               </a:lnSpc>
               <a:buNone/>
-              <a:defRPr sz="1950" b="0">
+              <a:defRPr sz="1875" b="0">
                 <a:solidFill>
                   <a:srgbClr val="222D32"/>
                 </a:solidFill>
@@ -16133,7 +16773,7 @@
               </a:defRPr>
             </a:pPr>
             <a:r>
-              <a:rPr sz="1950" b="0">
+              <a:rPr sz="1875" b="0">
                 <a:solidFill>
                   <a:srgbClr val="222D32"/>
                 </a:solidFill>
@@ -16148,10 +16788,10 @@
       </p:sp>
       <p:sp>
         <p:nvSpPr>
-          <p:cNvPr id="22" name="">
+          <p:cNvPr id="25" name="">
             <a:extLst xmlns:a="http://schemas.openxmlformats.org/drawingml/2006/main">
               <a:ext uri="{FF2B5EF4-FFF2-40B4-BE49-F238E27FC236}">
-                <a16:creationId xmlns:a16="http://schemas.microsoft.com/office/drawing/2014/main" id="{3BA73C0C-142D-4C2F-BDDB-36FDD1091ED7}"/>
+                <a16:creationId xmlns:a16="http://schemas.microsoft.com/office/drawing/2014/main" id="{767C3AD9-AF5E-4A28-8EEC-42EA46C960E0}"/>
               </a:ext>
             </a:extLst>
           </p:cNvPr>
@@ -16162,8 +16802,8 @@
         </p:nvSpPr>
         <p:spPr>
           <a:xfrm xmlns:a="http://schemas.openxmlformats.org/drawingml/2006/main">
-            <a:off x="7953375" y="4191000"/>
-            <a:ext cx="1809750" cy="285750"/>
+            <a:off x="7953375" y="4552950"/>
+            <a:ext cx="1809750" cy="257175"/>
           </a:xfrm>
           <a:prstGeom xmlns:a="http://schemas.openxmlformats.org/drawingml/2006/main" prst="rect">
             <a:avLst/>
@@ -16178,10 +16818,10 @@
       </p:sp>
       <p:sp>
         <p:nvSpPr>
-          <p:cNvPr id="23" name="">
+          <p:cNvPr id="26" name="">
             <a:extLst xmlns:a="http://schemas.openxmlformats.org/drawingml/2006/main">
               <a:ext uri="{FF2B5EF4-FFF2-40B4-BE49-F238E27FC236}">
-                <a16:creationId xmlns:a16="http://schemas.microsoft.com/office/drawing/2014/main" id="{2F502A41-ABB1-4E05-BA69-5220F72CED22}"/>
+                <a16:creationId xmlns:a16="http://schemas.microsoft.com/office/drawing/2014/main" id="{8EA0B52C-1FDE-4165-AADD-E269A68479FB}"/>
               </a:ext>
             </a:extLst>
           </p:cNvPr>
@@ -16192,8 +16832,8 @@
         </p:nvSpPr>
         <p:spPr>
           <a:xfrm xmlns:a="http://schemas.openxmlformats.org/drawingml/2006/main">
-            <a:off x="638175" y="4810125"/>
-            <a:ext cx="2695575" cy="409575"/>
+            <a:off x="638175" y="5010150"/>
+            <a:ext cx="2695575" cy="371475"/>
           </a:xfrm>
           <a:prstGeom xmlns:a="http://schemas.openxmlformats.org/drawingml/2006/main" prst="rect">
             <a:avLst/>
@@ -16207,7 +16847,7 @@
           <a:bodyPr xmlns:a="http://schemas.openxmlformats.org/drawingml/2006/main" wrap="square" lIns="0" tIns="0" rIns="0" bIns="0" anchor="t"/>
           <a:lstStyle xmlns:a="http://schemas.openxmlformats.org/drawingml/2006/main">
             <a:defPPr algn="l">
-              <a:defRPr sz="1950" b="0">
+              <a:defRPr sz="1875" b="0">
                 <a:solidFill>
                   <a:srgbClr val="222D32"/>
                 </a:solidFill>
@@ -16217,7 +16857,7 @@
               </a:defRPr>
             </a:defPPr>
             <a:lvl1pPr algn="l">
-              <a:defRPr sz="1950" b="0">
+              <a:defRPr sz="1875" b="0">
                 <a:solidFill>
                   <a:srgbClr val="222D32"/>
                 </a:solidFill>
@@ -16227,7 +16867,7 @@
               </a:defRPr>
             </a:lvl1pPr>
             <a:lvl2pPr algn="l">
-              <a:defRPr sz="1950" b="0">
+              <a:defRPr sz="1875" b="0">
                 <a:solidFill>
                   <a:srgbClr val="222D32"/>
                 </a:solidFill>
@@ -16237,7 +16877,7 @@
               </a:defRPr>
             </a:lvl2pPr>
             <a:lvl3pPr algn="l">
-              <a:defRPr sz="1950" b="0">
+              <a:defRPr sz="1875" b="0">
                 <a:solidFill>
                   <a:srgbClr val="222D32"/>
                 </a:solidFill>
@@ -16247,7 +16887,7 @@
               </a:defRPr>
             </a:lvl3pPr>
             <a:lvl4pPr algn="l">
-              <a:defRPr sz="1950" b="0">
+              <a:defRPr sz="1875" b="0">
                 <a:solidFill>
                   <a:srgbClr val="222D32"/>
                 </a:solidFill>
@@ -16257,7 +16897,7 @@
               </a:defRPr>
             </a:lvl4pPr>
             <a:lvl5pPr algn="l">
-              <a:defRPr sz="1950" b="0">
+              <a:defRPr sz="1875" b="0">
                 <a:solidFill>
                   <a:srgbClr val="222D32"/>
                 </a:solidFill>
@@ -16267,7 +16907,7 @@
               </a:defRPr>
             </a:lvl5pPr>
             <a:lvl6pPr algn="l">
-              <a:defRPr sz="1950" b="0">
+              <a:defRPr sz="1875" b="0">
                 <a:solidFill>
                   <a:srgbClr val="222D32"/>
                 </a:solidFill>
@@ -16277,7 +16917,7 @@
               </a:defRPr>
             </a:lvl6pPr>
             <a:lvl7pPr algn="l">
-              <a:defRPr sz="1950" b="0">
+              <a:defRPr sz="1875" b="0">
                 <a:solidFill>
                   <a:srgbClr val="222D32"/>
                 </a:solidFill>
@@ -16287,7 +16927,7 @@
               </a:defRPr>
             </a:lvl7pPr>
             <a:lvl8pPr algn="l">
-              <a:defRPr sz="1950" b="0">
+              <a:defRPr sz="1875" b="0">
                 <a:solidFill>
                   <a:srgbClr val="222D32"/>
                 </a:solidFill>
@@ -16297,7 +16937,7 @@
               </a:defRPr>
             </a:lvl8pPr>
             <a:lvl9pPr algn="l">
-              <a:defRPr sz="1950" b="0">
+              <a:defRPr sz="1875" b="0">
                 <a:solidFill>
                   <a:srgbClr val="222D32"/>
                 </a:solidFill>
@@ -16313,7 +16953,7 @@
                 <a:spcPct val="118000"/>
               </a:lnSpc>
               <a:buNone/>
-              <a:defRPr sz="1950" b="0">
+              <a:defRPr sz="1875" b="0">
                 <a:solidFill>
                   <a:srgbClr val="222D32"/>
                 </a:solidFill>
@@ -16323,7 +16963,7 @@
               </a:defRPr>
             </a:pPr>
             <a:r>
-              <a:rPr sz="1950" b="0">
+              <a:rPr sz="1875" b="0">
                 <a:solidFill>
                   <a:srgbClr val="222D32"/>
                 </a:solidFill>
@@ -16338,10 +16978,10 @@
       </p:sp>
       <p:sp>
         <p:nvSpPr>
-          <p:cNvPr id="24" name="">
+          <p:cNvPr id="27" name="">
             <a:extLst xmlns:a="http://schemas.openxmlformats.org/drawingml/2006/main">
               <a:ext uri="{FF2B5EF4-FFF2-40B4-BE49-F238E27FC236}">
-                <a16:creationId xmlns:a16="http://schemas.microsoft.com/office/drawing/2014/main" id="{0583EA55-7097-45FC-8ECF-E36DE42F8969}"/>
+                <a16:creationId xmlns:a16="http://schemas.microsoft.com/office/drawing/2014/main" id="{5144D64A-BE25-4225-A880-E6758610D86D}"/>
               </a:ext>
             </a:extLst>
           </p:cNvPr>
@@ -16352,8 +16992,8 @@
         </p:nvSpPr>
         <p:spPr>
           <a:xfrm xmlns:a="http://schemas.openxmlformats.org/drawingml/2006/main">
-            <a:off x="9810750" y="4857750"/>
-            <a:ext cx="1066800" cy="285750"/>
+            <a:off x="9810750" y="5057775"/>
+            <a:ext cx="1066800" cy="257175"/>
           </a:xfrm>
           <a:prstGeom xmlns:a="http://schemas.openxmlformats.org/drawingml/2006/main" prst="rect">
             <a:avLst/>
@@ -16368,10 +17008,10 @@
       </p:sp>
       <p:sp>
         <p:nvSpPr>
-          <p:cNvPr id="25" name="">
+          <p:cNvPr id="28" name="">
             <a:extLst xmlns:a="http://schemas.openxmlformats.org/drawingml/2006/main">
               <a:ext uri="{FF2B5EF4-FFF2-40B4-BE49-F238E27FC236}">
-                <a16:creationId xmlns:a16="http://schemas.microsoft.com/office/drawing/2014/main" id="{01752064-6DD5-41D5-816F-CB0910608E38}"/>
+                <a16:creationId xmlns:a16="http://schemas.microsoft.com/office/drawing/2014/main" id="{8C93A649-EA01-49CF-975D-658D9CA06F57}"/>
               </a:ext>
             </a:extLst>
           </p:cNvPr>
@@ -16529,7 +17169,7 @@
     </p:spTree>
     <p:extLst>
       <p:ext uri="{BB962C8B-B14F-4D97-AF65-F5344CB8AC3E}">
-        <p14:creationId xmlns:p14="http://schemas.microsoft.com/office/powerpoint/2010/main" val="1971769288"/>
+        <p14:creationId xmlns:p14="http://schemas.microsoft.com/office/powerpoint/2010/main" val="1282381680"/>
       </p:ext>
     </p:extLst>
   </p:cSld>
@@ -16560,7 +17200,7 @@
           <p:cNvPr id="6" name="">
             <a:extLst xmlns:a="http://schemas.openxmlformats.org/drawingml/2006/main">
               <a:ext uri="{FF2B5EF4-FFF2-40B4-BE49-F238E27FC236}">
-                <a16:creationId xmlns:a16="http://schemas.microsoft.com/office/drawing/2014/main" id="{33FFFAA1-7AB6-4808-A4EF-1494736FAA54}"/>
+                <a16:creationId xmlns:a16="http://schemas.microsoft.com/office/drawing/2014/main" id="{6612BE09-BDF8-4A97-87CD-0408027DCDFE}"/>
               </a:ext>
             </a:extLst>
           </p:cNvPr>
@@ -16720,7 +17360,7 @@
           <p:cNvPr id="2" name="">
             <a:extLst xmlns:a="http://schemas.openxmlformats.org/drawingml/2006/main">
               <a:ext uri="{FF2B5EF4-FFF2-40B4-BE49-F238E27FC236}">
-                <a16:creationId xmlns:a16="http://schemas.microsoft.com/office/drawing/2014/main" id="{FD0E3D18-CA12-4D67-A566-6F51BD8C0549}"/>
+                <a16:creationId xmlns:a16="http://schemas.microsoft.com/office/drawing/2014/main" id="{01639729-02BA-4B42-8E11-E40E9068BD10}"/>
               </a:ext>
             </a:extLst>
           </p:cNvPr>
@@ -16880,7 +17520,7 @@
           <p:cNvPr id="3" name="">
             <a:extLst xmlns:a="http://schemas.openxmlformats.org/drawingml/2006/main">
               <a:ext uri="{FF2B5EF4-FFF2-40B4-BE49-F238E27FC236}">
-                <a16:creationId xmlns:a16="http://schemas.microsoft.com/office/drawing/2014/main" id="{40BD9359-86B8-4D4C-9B14-A7D736AA35A7}"/>
+                <a16:creationId xmlns:a16="http://schemas.microsoft.com/office/drawing/2014/main" id="{74B4DB18-1250-443E-9F7E-208BE685420A}"/>
               </a:ext>
             </a:extLst>
           </p:cNvPr>
@@ -16890,7 +17530,7 @@
           <p:nvPr/>
         </p:nvPicPr>
         <p:blipFill>
-          <a:blip xmlns:r="http://schemas.openxmlformats.org/officeDocument/2006/relationships" xmlns:a="http://schemas.openxmlformats.org/drawingml/2006/main" r:embed="R0d64a24a3dc24ab4"/>
+          <a:blip xmlns:r="http://schemas.openxmlformats.org/officeDocument/2006/relationships" xmlns:a="http://schemas.openxmlformats.org/drawingml/2006/main" r:embed="R11aa106d56b048fe"/>
           <a:stretch xmlns:a="http://schemas.openxmlformats.org/drawingml/2006/main"/>
         </p:blipFill>
         <p:spPr>
@@ -16908,7 +17548,7 @@
           <p:cNvPr id="4" name="">
             <a:extLst xmlns:a="http://schemas.openxmlformats.org/drawingml/2006/main">
               <a:ext uri="{FF2B5EF4-FFF2-40B4-BE49-F238E27FC236}">
-                <a16:creationId xmlns:a16="http://schemas.microsoft.com/office/drawing/2014/main" id="{EB6D1A68-9F16-4853-87A4-88A2652E8670}"/>
+                <a16:creationId xmlns:a16="http://schemas.microsoft.com/office/drawing/2014/main" id="{E99C0712-0E88-4281-AC6A-D3DDE0DB8B93}"/>
               </a:ext>
             </a:extLst>
           </p:cNvPr>
@@ -17164,7 +17804,7 @@
           <p:cNvPr id="5" name="">
             <a:extLst xmlns:a="http://schemas.openxmlformats.org/drawingml/2006/main">
               <a:ext uri="{FF2B5EF4-FFF2-40B4-BE49-F238E27FC236}">
-                <a16:creationId xmlns:a16="http://schemas.microsoft.com/office/drawing/2014/main" id="{CBEDE2EB-FF4E-44EB-B3C7-9F34B6ED1B4B}"/>
+                <a16:creationId xmlns:a16="http://schemas.microsoft.com/office/drawing/2014/main" id="{ED9BF1D1-38B7-45FC-A9BD-009E13BFF25B}"/>
               </a:ext>
             </a:extLst>
           </p:cNvPr>
@@ -17349,7 +17989,7 @@
     </p:spTree>
     <p:extLst>
       <p:ext uri="{BB962C8B-B14F-4D97-AF65-F5344CB8AC3E}">
-        <p14:creationId xmlns:p14="http://schemas.microsoft.com/office/powerpoint/2010/main" val="293306528"/>
+        <p14:creationId xmlns:p14="http://schemas.microsoft.com/office/powerpoint/2010/main" val="453698572"/>
       </p:ext>
     </p:extLst>
   </p:cSld>

</xml_diff>